<commit_message>
Black deck back to the original colourful design
The black deck drops the muted styles and keeps the original colourful
slides, in IG cyan, yellow and magenta only (violet, green, navy and
orange mapped to IG colours), with thinner borders, the bronze/silver/
gold data boxes, the 7pt minimum and the Sierra key-differentiator tag.
Platform fit gets a colourful mode and numberless concurrency headings
(fair share for every pod; scales with demand) in both decks. The
white deck keeps its muted style.

Co-Authored-By: Claude Opus 5.5 <noreply@anthropic.com>
Claude-Session: https://claude.ai/code/session_01Hf94kqMzSofkkrQm7kpNba
</commit_message>
<xml_diff>
--- a/poc/data_harness/Ascension Agentic Harness - Data Harness (white).pptx
+++ b/poc/data_harness/Ascension Agentic Harness - Data Harness (white).pptx
@@ -1501,7 +1501,7 @@
           </a:p>
           <a:p>
             <a:r>
-              <a:t>- How it scales (concurrency): each request is its own isolated run; up to 3 runs per pod so no pod crowds out another; about 30 at once, set by model and API quotas (proposed, sized in the Phase 0 load test); extra requests wait, none are dropped.</a:t>
+              <a:t>- How it scales (concurrency): each request is its own isolated run; fair share for every pod, a per-pod cap set in config so no pod crowds out another; scales with demand within model and API quotas, sized in the Phase 0 load test; extra requests wait, none are dropped. If asked for numbers: our starting design is a few runs per pod and a few dozen overall, both settings.</a:t>
             </a:r>
           </a:p>
           <a:p>
@@ -5507,7 +5507,7 @@
                 </a:solidFill>
                 <a:latin typeface="Trenda IG Text"/>
               </a:rPr>
-              <a:t>Up to 3 runs per pod</a:t>
+              <a:t>Fair share for every pod</a:t>
             </a:r>
           </a:p>
           <a:p>
@@ -5523,7 +5523,7 @@
                 </a:solidFill>
                 <a:latin typeface="Trenda IG Text"/>
               </a:rPr>
-              <a:t>fair share: no pod crowds out another</a:t>
+              <a:t>a per-pod cap, set in config: no pod crowds out another</a:t>
             </a:r>
           </a:p>
         </p:txBody>
@@ -5646,7 +5646,7 @@
                 </a:solidFill>
                 <a:latin typeface="Trenda IG Text"/>
               </a:rPr>
-              <a:t>About 30 runs at once</a:t>
+              <a:t>Scales with demand</a:t>
             </a:r>
           </a:p>
           <a:p>
@@ -5662,7 +5662,7 @@
                 </a:solidFill>
                 <a:latin typeface="Trenda IG Text"/>
               </a:rPr>
-              <a:t>set by model and API quotas; proposed, sized in the Phase 0 load test</a:t>
+              <a:t>runs added as load grows, within model and API quotas; sized in Phase 0</a:t>
             </a:r>
           </a:p>
         </p:txBody>

</xml_diff>

<commit_message>
Apply the architect's valid fixes to both decks
Slide 2: Agent sources (read + write via the gateway); agent or owner
named in every path bubble; duplicate Human approval bubble removed
(UAT is the business step); Change Guardian named with the Architect
Agent; requirements as user stories and functional decomposition.
Slide 3: Change Guardian highlighted with a WE BUILD IT tag and in
differentiator 2. Slide 4: user stories and functional decomposition
from the Jira story.

Co-Authored-By: Claude Opus 5.5 <noreply@anthropic.com>
Claude-Session: https://claude.ai/code/session_01Hf94kqMzSofkkrQm7kpNba
</commit_message>
<xml_diff>
--- a/poc/data_harness/Ascension Agentic Harness - Data Harness (white).pptx
+++ b/poc/data_harness/Ascension Agentic Harness - Data Harness (white).pptx
@@ -1703,7 +1703,7 @@
           </a:p>
           <a:p>
             <a:r>
-              <a:t>- Left: what the agents read. The engineering sources (Jira, Confluence, Salesforce, Git, Copado, Drive) for every pod. For Marketing Cloud pods, governed Google Cloud data: Gold A aggregates and masked views only.</a:t>
+              <a:t>- Left: agent sources. Agents read from and write to these systems, always through the tool gateway and never in production. The engineering sources (Jira, Confluence, Salesforce, Git, Copado, Drive) for every pod. For Marketing Cloud pods, governed Google Cloud data: Gold A aggregates and masked views only.</a:t>
             </a:r>
           </a:p>
           <a:p>
@@ -1723,7 +1723,12 @@
           </a:p>
           <a:p>
             <a:r>
-              <a:t>- Bottom: two governed paths. The delivery path is unchanged; the campaign path builds and tests first, then a masked pre-send review, then release through the gateway.</a:t>
+              <a:t>- Bottom: two governed paths, with who does each step. Delivery: the Developer Agent builds, the Release Agent moves it through Copado, Review and Test Agents run the quality gates; business users sign UAT and the change board approves at CAB. Campaigns: the Orchestrator takes the prompt, Strategist and Analytics plan on Gold A, Design and Readiness build and test, the SME and tech lead review before send, and the policy service releases.</a:t>
+            </a:r>
+          </a:p>
+          <a:p>
+            <a:r>
+              <a:t>- The Change Guardian sits with the Architect Agent: it flags any change that affects another pod before anything is built.</a:t>
             </a:r>
           </a:p>
         </p:txBody>
@@ -13060,7 +13065,16 @@
                 </a:solidFill>
                 <a:latin typeface="Trenda IG Text"/>
               </a:rPr>
-              <a:t>WHAT AGENTS READ</a:t>
+              <a:t>AGENT SOURCES</a:t>
+            </a:r>
+            <a:r>
+              <a:rPr sz="700" b="0" i="0">
+                <a:solidFill>
+                  <a:srgbClr val="1A1A1A"/>
+                </a:solidFill>
+                <a:latin typeface="Trenda IG Text"/>
+              </a:rPr>
+              <a:t>   read + write via the gateway</a:t>
             </a:r>
           </a:p>
         </p:txBody>
@@ -14317,7 +14331,7 @@
                 </a:solidFill>
                 <a:latin typeface="Trenda IG Text"/>
               </a:rPr>
-              <a:t>Jira story and Confluence design into a clear brief</a:t>
+              <a:t>User stories and functional decomposition from the Jira story</a:t>
             </a:r>
           </a:p>
         </p:txBody>
@@ -14583,7 +14597,25 @@
                 </a:solidFill>
                 <a:latin typeface="Trenda IG Text"/>
               </a:rPr>
-              <a:t>Impact, reuse and risk from the graph; the change plan</a:t>
+              <a:t>Impact and reuse from the graph; </a:t>
+            </a:r>
+            <a:r>
+              <a:rPr sz="700" b="1" i="0">
+                <a:solidFill>
+                  <a:srgbClr val="1A1A1A"/>
+                </a:solidFill>
+                <a:latin typeface="Trenda IG Text"/>
+              </a:rPr>
+              <a:t>Change Guardian</a:t>
+            </a:r>
+            <a:r>
+              <a:rPr sz="700" b="0" i="0">
+                <a:solidFill>
+                  <a:srgbClr val="4D4D4D"/>
+                </a:solidFill>
+                <a:latin typeface="Trenda IG Text"/>
+              </a:rPr>
+              <a:t> flags cross-pod risk</a:t>
             </a:r>
           </a:p>
         </p:txBody>
@@ -18484,8 +18516,8 @@
         </p:nvSpPr>
         <p:spPr>
           <a:xfrm>
-            <a:off x="411480" y="5559552"/>
-            <a:ext cx="1188720" cy="292608"/>
+            <a:off x="411480" y="5504688"/>
+            <a:ext cx="1188720" cy="347472"/>
           </a:xfrm>
           <a:prstGeom prst="rect">
             <a:avLst/>
@@ -18518,8 +18550,8 @@
         </p:nvSpPr>
         <p:spPr>
           <a:xfrm>
-            <a:off x="1645920" y="5559552"/>
-            <a:ext cx="1060704" cy="292608"/>
+            <a:off x="1645920" y="5504688"/>
+            <a:ext cx="1202436" cy="347472"/>
           </a:xfrm>
           <a:prstGeom prst="roundRect">
             <a:avLst>
@@ -18564,8 +18596,8 @@
         </p:nvSpPr>
         <p:spPr>
           <a:xfrm>
-            <a:off x="1645920" y="5559552"/>
-            <a:ext cx="1060704" cy="292608"/>
+            <a:off x="1645920" y="5504688"/>
+            <a:ext cx="1202436" cy="347472"/>
           </a:xfrm>
           <a:prstGeom prst="rect">
             <a:avLst/>
@@ -18578,15 +18610,35 @@
           </a:bodyPr>
           <a:lstStyle/>
           <a:p>
-            <a:pPr algn="ctr"/>
+            <a:pPr algn="ctr">
+              <a:lnSpc>
+                <a:spcPct val="90000"/>
+              </a:lnSpc>
+            </a:pPr>
+            <a:r>
+              <a:rPr sz="700" b="1" i="0">
+                <a:solidFill>
+                  <a:srgbClr val="1A1A1A"/>
+                </a:solidFill>
+                <a:latin typeface="Trenda IG Text"/>
+              </a:rPr>
+              <a:t>AI build</a:t>
+            </a:r>
+          </a:p>
+          <a:p>
+            <a:pPr algn="ctr">
+              <a:lnSpc>
+                <a:spcPct val="90000"/>
+              </a:lnSpc>
+            </a:pPr>
             <a:r>
               <a:rPr sz="700" b="0" i="0">
                 <a:solidFill>
-                  <a:srgbClr val="1A1A1A"/>
-                </a:solidFill>
-                <a:latin typeface="Trenda IG Text"/>
-              </a:rPr>
-              <a:t>AI build</a:t>
+                  <a:srgbClr val="4D4D4D"/>
+                </a:solidFill>
+                <a:latin typeface="Trenda IG Text"/>
+              </a:rPr>
+              <a:t>Developer Agent</a:t>
             </a:r>
           </a:p>
         </p:txBody>
@@ -18599,7 +18651,7 @@
         </p:nvCxnSpPr>
         <p:spPr>
           <a:xfrm>
-            <a:off x="2706624" y="5705856"/>
+            <a:off x="2848356" y="5678424"/>
             <a:ext cx="73152" cy="0"/>
           </a:xfrm>
           <a:prstGeom prst="line">
@@ -18635,8 +18687,8 @@
         </p:nvSpPr>
         <p:spPr>
           <a:xfrm>
-            <a:off x="2779776" y="5559552"/>
-            <a:ext cx="1060704" cy="292608"/>
+            <a:off x="2921508" y="5504688"/>
+            <a:ext cx="1202436" cy="347472"/>
           </a:xfrm>
           <a:prstGeom prst="roundRect">
             <a:avLst>
@@ -18681,8 +18733,8 @@
         </p:nvSpPr>
         <p:spPr>
           <a:xfrm>
-            <a:off x="2779776" y="5559552"/>
-            <a:ext cx="1060704" cy="292608"/>
+            <a:off x="2921508" y="5504688"/>
+            <a:ext cx="1202436" cy="347472"/>
           </a:xfrm>
           <a:prstGeom prst="rect">
             <a:avLst/>
@@ -18695,15 +18747,35 @@
           </a:bodyPr>
           <a:lstStyle/>
           <a:p>
-            <a:pPr algn="ctr"/>
+            <a:pPr algn="ctr">
+              <a:lnSpc>
+                <a:spcPct val="90000"/>
+              </a:lnSpc>
+            </a:pPr>
+            <a:r>
+              <a:rPr sz="700" b="1" i="0">
+                <a:solidFill>
+                  <a:srgbClr val="1A1A1A"/>
+                </a:solidFill>
+                <a:latin typeface="Trenda IG Text"/>
+              </a:rPr>
+              <a:t>Copado</a:t>
+            </a:r>
+          </a:p>
+          <a:p>
+            <a:pPr algn="ctr">
+              <a:lnSpc>
+                <a:spcPct val="90000"/>
+              </a:lnSpc>
+            </a:pPr>
             <a:r>
               <a:rPr sz="700" b="0" i="0">
                 <a:solidFill>
-                  <a:srgbClr val="1A1A1A"/>
-                </a:solidFill>
-                <a:latin typeface="Trenda IG Text"/>
-              </a:rPr>
-              <a:t>Copado</a:t>
+                  <a:srgbClr val="4D4D4D"/>
+                </a:solidFill>
+                <a:latin typeface="Trenda IG Text"/>
+              </a:rPr>
+              <a:t>Release Agent</a:t>
             </a:r>
           </a:p>
         </p:txBody>
@@ -18716,7 +18788,7 @@
         </p:nvCxnSpPr>
         <p:spPr>
           <a:xfrm>
-            <a:off x="3840480" y="5705856"/>
+            <a:off x="4123944" y="5678424"/>
             <a:ext cx="73152" cy="0"/>
           </a:xfrm>
           <a:prstGeom prst="line">
@@ -18752,8 +18824,8 @@
         </p:nvSpPr>
         <p:spPr>
           <a:xfrm>
-            <a:off x="3913632" y="5559552"/>
-            <a:ext cx="1060704" cy="292608"/>
+            <a:off x="4197096" y="5504688"/>
+            <a:ext cx="1202436" cy="347472"/>
           </a:xfrm>
           <a:prstGeom prst="roundRect">
             <a:avLst>
@@ -18798,8 +18870,8 @@
         </p:nvSpPr>
         <p:spPr>
           <a:xfrm>
-            <a:off x="3913632" y="5559552"/>
-            <a:ext cx="1060704" cy="292608"/>
+            <a:off x="4197096" y="5504688"/>
+            <a:ext cx="1202436" cy="347472"/>
           </a:xfrm>
           <a:prstGeom prst="rect">
             <a:avLst/>
@@ -18812,15 +18884,35 @@
           </a:bodyPr>
           <a:lstStyle/>
           <a:p>
-            <a:pPr algn="ctr"/>
+            <a:pPr algn="ctr">
+              <a:lnSpc>
+                <a:spcPct val="90000"/>
+              </a:lnSpc>
+            </a:pPr>
+            <a:r>
+              <a:rPr sz="700" b="1" i="0">
+                <a:solidFill>
+                  <a:srgbClr val="1A1A1A"/>
+                </a:solidFill>
+                <a:latin typeface="Trenda IG Text"/>
+              </a:rPr>
+              <a:t>Quality gates</a:t>
+            </a:r>
+          </a:p>
+          <a:p>
+            <a:pPr algn="ctr">
+              <a:lnSpc>
+                <a:spcPct val="90000"/>
+              </a:lnSpc>
+            </a:pPr>
             <a:r>
               <a:rPr sz="700" b="0" i="0">
                 <a:solidFill>
-                  <a:srgbClr val="1A1A1A"/>
-                </a:solidFill>
-                <a:latin typeface="Trenda IG Text"/>
-              </a:rPr>
-              <a:t>Quality gates</a:t>
+                  <a:srgbClr val="4D4D4D"/>
+                </a:solidFill>
+                <a:latin typeface="Trenda IG Text"/>
+              </a:rPr>
+              <a:t>Review + Test Agents</a:t>
             </a:r>
           </a:p>
         </p:txBody>
@@ -18833,7 +18925,7 @@
         </p:nvCxnSpPr>
         <p:spPr>
           <a:xfrm>
-            <a:off x="4974336" y="5705856"/>
+            <a:off x="5399531" y="5678424"/>
             <a:ext cx="73152" cy="0"/>
           </a:xfrm>
           <a:prstGeom prst="line">
@@ -18869,8 +18961,8 @@
         </p:nvSpPr>
         <p:spPr>
           <a:xfrm>
-            <a:off x="5047488" y="5559552"/>
-            <a:ext cx="1060704" cy="292608"/>
+            <a:off x="5472683" y="5504688"/>
+            <a:ext cx="1202436" cy="347472"/>
           </a:xfrm>
           <a:prstGeom prst="roundRect">
             <a:avLst>
@@ -18915,8 +19007,8 @@
         </p:nvSpPr>
         <p:spPr>
           <a:xfrm>
-            <a:off x="5047488" y="5559552"/>
-            <a:ext cx="1060704" cy="292608"/>
+            <a:off x="5472683" y="5504688"/>
+            <a:ext cx="1202436" cy="347472"/>
           </a:xfrm>
           <a:prstGeom prst="rect">
             <a:avLst/>
@@ -18929,15 +19021,35 @@
           </a:bodyPr>
           <a:lstStyle/>
           <a:p>
-            <a:pPr algn="ctr"/>
+            <a:pPr algn="ctr">
+              <a:lnSpc>
+                <a:spcPct val="90000"/>
+              </a:lnSpc>
+            </a:pPr>
+            <a:r>
+              <a:rPr sz="700" b="1" i="0">
+                <a:solidFill>
+                  <a:srgbClr val="1A1A1A"/>
+                </a:solidFill>
+                <a:latin typeface="Trenda IG Text"/>
+              </a:rPr>
+              <a:t>DEV</a:t>
+            </a:r>
+          </a:p>
+          <a:p>
+            <a:pPr algn="ctr">
+              <a:lnSpc>
+                <a:spcPct val="90000"/>
+              </a:lnSpc>
+            </a:pPr>
             <a:r>
               <a:rPr sz="700" b="0" i="0">
                 <a:solidFill>
-                  <a:srgbClr val="1A1A1A"/>
-                </a:solidFill>
-                <a:latin typeface="Trenda IG Text"/>
-              </a:rPr>
-              <a:t>DEV</a:t>
+                  <a:srgbClr val="4D4D4D"/>
+                </a:solidFill>
+                <a:latin typeface="Trenda IG Text"/>
+              </a:rPr>
+              <a:t>Release Agent</a:t>
             </a:r>
           </a:p>
         </p:txBody>
@@ -18950,7 +19062,7 @@
         </p:nvCxnSpPr>
         <p:spPr>
           <a:xfrm>
-            <a:off x="6108192" y="5705856"/>
+            <a:off x="6675119" y="5678424"/>
             <a:ext cx="73152" cy="0"/>
           </a:xfrm>
           <a:prstGeom prst="line">
@@ -18986,8 +19098,8 @@
         </p:nvSpPr>
         <p:spPr>
           <a:xfrm>
-            <a:off x="6181344" y="5559552"/>
-            <a:ext cx="1060704" cy="292608"/>
+            <a:off x="6748271" y="5504688"/>
+            <a:ext cx="1202436" cy="347472"/>
           </a:xfrm>
           <a:prstGeom prst="roundRect">
             <a:avLst>
@@ -19032,8 +19144,8 @@
         </p:nvSpPr>
         <p:spPr>
           <a:xfrm>
-            <a:off x="6181344" y="5559552"/>
-            <a:ext cx="1060704" cy="292608"/>
+            <a:off x="6748271" y="5504688"/>
+            <a:ext cx="1202436" cy="347472"/>
           </a:xfrm>
           <a:prstGeom prst="rect">
             <a:avLst/>
@@ -19046,15 +19158,35 @@
           </a:bodyPr>
           <a:lstStyle/>
           <a:p>
-            <a:pPr algn="ctr"/>
+            <a:pPr algn="ctr">
+              <a:lnSpc>
+                <a:spcPct val="90000"/>
+              </a:lnSpc>
+            </a:pPr>
+            <a:r>
+              <a:rPr sz="700" b="1" i="0">
+                <a:solidFill>
+                  <a:srgbClr val="1A1A1A"/>
+                </a:solidFill>
+                <a:latin typeface="Trenda IG Text"/>
+              </a:rPr>
+              <a:t>SIT</a:t>
+            </a:r>
+          </a:p>
+          <a:p>
+            <a:pPr algn="ctr">
+              <a:lnSpc>
+                <a:spcPct val="90000"/>
+              </a:lnSpc>
+            </a:pPr>
             <a:r>
               <a:rPr sz="700" b="0" i="0">
                 <a:solidFill>
-                  <a:srgbClr val="1A1A1A"/>
-                </a:solidFill>
-                <a:latin typeface="Trenda IG Text"/>
-              </a:rPr>
-              <a:t>SIT</a:t>
+                  <a:srgbClr val="4D4D4D"/>
+                </a:solidFill>
+                <a:latin typeface="Trenda IG Text"/>
+              </a:rPr>
+              <a:t>Test Agent</a:t>
             </a:r>
           </a:p>
         </p:txBody>
@@ -19067,7 +19199,7 @@
         </p:nvCxnSpPr>
         <p:spPr>
           <a:xfrm>
-            <a:off x="7242048" y="5705856"/>
+            <a:off x="7950707" y="5678424"/>
             <a:ext cx="73152" cy="0"/>
           </a:xfrm>
           <a:prstGeom prst="line">
@@ -19103,8 +19235,8 @@
         </p:nvSpPr>
         <p:spPr>
           <a:xfrm>
-            <a:off x="7315200" y="5559552"/>
-            <a:ext cx="1060704" cy="292608"/>
+            <a:off x="8023859" y="5504688"/>
+            <a:ext cx="1202436" cy="347472"/>
           </a:xfrm>
           <a:prstGeom prst="roundRect">
             <a:avLst>
@@ -19149,8 +19281,8 @@
         </p:nvSpPr>
         <p:spPr>
           <a:xfrm>
-            <a:off x="7315200" y="5559552"/>
-            <a:ext cx="1060704" cy="292608"/>
+            <a:off x="8023859" y="5504688"/>
+            <a:ext cx="1202436" cy="347472"/>
           </a:xfrm>
           <a:prstGeom prst="rect">
             <a:avLst/>
@@ -19163,7 +19295,11 @@
           </a:bodyPr>
           <a:lstStyle/>
           <a:p>
-            <a:pPr algn="ctr"/>
+            <a:pPr algn="ctr">
+              <a:lnSpc>
+                <a:spcPct val="90000"/>
+              </a:lnSpc>
+            </a:pPr>
             <a:r>
               <a:rPr sz="700" b="1" i="0">
                 <a:solidFill>
@@ -19172,6 +19308,22 @@
                 <a:latin typeface="Trenda IG Text"/>
               </a:rPr>
               <a:t>UAT</a:t>
+            </a:r>
+          </a:p>
+          <a:p>
+            <a:pPr algn="ctr">
+              <a:lnSpc>
+                <a:spcPct val="90000"/>
+              </a:lnSpc>
+            </a:pPr>
+            <a:r>
+              <a:rPr sz="700" b="0" i="0">
+                <a:solidFill>
+                  <a:srgbClr val="0089A0"/>
+                </a:solidFill>
+                <a:latin typeface="Trenda IG Text"/>
+              </a:rPr>
+              <a:t>business users</a:t>
             </a:r>
           </a:p>
         </p:txBody>
@@ -19184,7 +19336,7 @@
         </p:nvCxnSpPr>
         <p:spPr>
           <a:xfrm>
-            <a:off x="8375904" y="5705856"/>
+            <a:off x="9226295" y="5678424"/>
             <a:ext cx="73152" cy="0"/>
           </a:xfrm>
           <a:prstGeom prst="line">
@@ -19220,8 +19372,8 @@
         </p:nvSpPr>
         <p:spPr>
           <a:xfrm>
-            <a:off x="8449056" y="5559552"/>
-            <a:ext cx="1060704" cy="292608"/>
+            <a:off x="9299447" y="5504688"/>
+            <a:ext cx="1202436" cy="347472"/>
           </a:xfrm>
           <a:prstGeom prst="roundRect">
             <a:avLst>
@@ -19266,8 +19418,8 @@
         </p:nvSpPr>
         <p:spPr>
           <a:xfrm>
-            <a:off x="8449056" y="5559552"/>
-            <a:ext cx="1060704" cy="292608"/>
+            <a:off x="9299447" y="5504688"/>
+            <a:ext cx="1202436" cy="347472"/>
           </a:xfrm>
           <a:prstGeom prst="rect">
             <a:avLst/>
@@ -19280,7 +19432,11 @@
           </a:bodyPr>
           <a:lstStyle/>
           <a:p>
-            <a:pPr algn="ctr"/>
+            <a:pPr algn="ctr">
+              <a:lnSpc>
+                <a:spcPct val="90000"/>
+              </a:lnSpc>
+            </a:pPr>
             <a:r>
               <a:rPr sz="700" b="1" i="0">
                 <a:solidFill>
@@ -19288,7 +19444,23 @@
                 </a:solidFill>
                 <a:latin typeface="Trenda IG Text"/>
               </a:rPr>
-              <a:t>Human approval</a:t>
+              <a:t>CAB</a:t>
+            </a:r>
+          </a:p>
+          <a:p>
+            <a:pPr algn="ctr">
+              <a:lnSpc>
+                <a:spcPct val="90000"/>
+              </a:lnSpc>
+            </a:pPr>
+            <a:r>
+              <a:rPr sz="700" b="0" i="0">
+                <a:solidFill>
+                  <a:srgbClr val="0089A0"/>
+                </a:solidFill>
+                <a:latin typeface="Trenda IG Text"/>
+              </a:rPr>
+              <a:t>change board</a:t>
             </a:r>
           </a:p>
         </p:txBody>
@@ -19301,7 +19473,7 @@
         </p:nvCxnSpPr>
         <p:spPr>
           <a:xfrm>
-            <a:off x="9509760" y="5705856"/>
+            <a:off x="10501883" y="5678424"/>
             <a:ext cx="73152" cy="0"/>
           </a:xfrm>
           <a:prstGeom prst="line">
@@ -19337,8 +19509,143 @@
         </p:nvSpPr>
         <p:spPr>
           <a:xfrm>
-            <a:off x="9582912" y="5559552"/>
-            <a:ext cx="1060704" cy="292608"/>
+            <a:off x="10575035" y="5504688"/>
+            <a:ext cx="1202436" cy="347472"/>
+          </a:xfrm>
+          <a:prstGeom prst="roundRect">
+            <a:avLst>
+              <a:gd name="adj" fmla="val 30000"/>
+            </a:avLst>
+          </a:prstGeom>
+          <a:solidFill>
+            <a:srgbClr val="F5F5F5"/>
+          </a:solidFill>
+          <a:ln w="11430">
+            <a:solidFill>
+              <a:srgbClr val="BDBDBD"/>
+            </a:solidFill>
+          </a:ln>
+          <a:effectLst/>
+        </p:spPr>
+        <p:style>
+          <a:lnRef idx="1">
+            <a:schemeClr val="accent1"/>
+          </a:lnRef>
+          <a:fillRef idx="3">
+            <a:schemeClr val="accent1"/>
+          </a:fillRef>
+          <a:effectRef idx="2">
+            <a:schemeClr val="accent1"/>
+          </a:effectRef>
+          <a:fontRef idx="minor">
+            <a:schemeClr val="lt1"/>
+          </a:fontRef>
+        </p:style>
+        <p:txBody>
+          <a:bodyPr rtlCol="0" anchor="ctr"/>
+          <a:lstStyle/>
+          <a:p/>
+        </p:txBody>
+      </p:sp>
+      <p:sp>
+        <p:nvSpPr>
+          <p:cNvPr id="174" name="Text 165"/>
+          <p:cNvSpPr txBox="1"/>
+          <p:nvPr/>
+        </p:nvSpPr>
+        <p:spPr>
+          <a:xfrm>
+            <a:off x="10575035" y="5504688"/>
+            <a:ext cx="1202436" cy="347472"/>
+          </a:xfrm>
+          <a:prstGeom prst="rect">
+            <a:avLst/>
+          </a:prstGeom>
+          <a:noFill/>
+        </p:spPr>
+        <p:txBody>
+          <a:bodyPr wrap="square" lIns="0" rIns="0" tIns="0" bIns="0" anchor="ctr">
+            <a:spAutoFit/>
+          </a:bodyPr>
+          <a:lstStyle/>
+          <a:p>
+            <a:pPr algn="ctr">
+              <a:lnSpc>
+                <a:spcPct val="90000"/>
+              </a:lnSpc>
+            </a:pPr>
+            <a:r>
+              <a:rPr sz="700" b="1" i="0">
+                <a:solidFill>
+                  <a:srgbClr val="1A1A1A"/>
+                </a:solidFill>
+                <a:latin typeface="Trenda IG Text"/>
+              </a:rPr>
+              <a:t>PROD</a:t>
+            </a:r>
+          </a:p>
+          <a:p>
+            <a:pPr algn="ctr">
+              <a:lnSpc>
+                <a:spcPct val="90000"/>
+              </a:lnSpc>
+            </a:pPr>
+            <a:r>
+              <a:rPr sz="700" b="0" i="0">
+                <a:solidFill>
+                  <a:srgbClr val="4D4D4D"/>
+                </a:solidFill>
+                <a:latin typeface="Trenda IG Text"/>
+              </a:rPr>
+              <a:t>owning team</a:t>
+            </a:r>
+          </a:p>
+        </p:txBody>
+      </p:sp>
+      <p:sp>
+        <p:nvSpPr>
+          <p:cNvPr id="175" name="Text 166"/>
+          <p:cNvSpPr txBox="1"/>
+          <p:nvPr/>
+        </p:nvSpPr>
+        <p:spPr>
+          <a:xfrm>
+            <a:off x="411480" y="5907024"/>
+            <a:ext cx="1188720" cy="347472"/>
+          </a:xfrm>
+          <a:prstGeom prst="rect">
+            <a:avLst/>
+          </a:prstGeom>
+          <a:noFill/>
+        </p:spPr>
+        <p:txBody>
+          <a:bodyPr wrap="square" lIns="0" rIns="0" tIns="0" bIns="0" anchor="ctr">
+            <a:spAutoFit/>
+          </a:bodyPr>
+          <a:lstStyle/>
+          <a:p>
+            <a:r>
+              <a:rPr sz="700" b="1" i="0" spc="120">
+                <a:solidFill>
+                  <a:srgbClr val="0089A0"/>
+                </a:solidFill>
+                <a:latin typeface="Trenda IG Text"/>
+              </a:rPr>
+              <a:t>CAMPAIGN PATH</a:t>
+            </a:r>
+          </a:p>
+        </p:txBody>
+      </p:sp>
+      <p:sp>
+        <p:nvSpPr>
+          <p:cNvPr id="176" name="Shape 167"/>
+          <p:cNvSpPr/>
+          <p:nvPr/>
+        </p:nvSpPr>
+        <p:spPr>
+          <a:xfrm>
+            <a:off x="1645920" y="5907024"/>
+            <a:ext cx="1627632" cy="347472"/>
           </a:xfrm>
           <a:prstGeom prst="roundRect">
             <a:avLst>
@@ -19377,14 +19684,14 @@
       </p:sp>
       <p:sp>
         <p:nvSpPr>
-          <p:cNvPr id="174" name="Text 165"/>
-          <p:cNvSpPr txBox="1"/>
-          <p:nvPr/>
-        </p:nvSpPr>
-        <p:spPr>
-          <a:xfrm>
-            <a:off x="9582912" y="5559552"/>
-            <a:ext cx="1060704" cy="292608"/>
+          <p:cNvPr id="177" name="Text 168"/>
+          <p:cNvSpPr txBox="1"/>
+          <p:nvPr/>
+        </p:nvSpPr>
+        <p:spPr>
+          <a:xfrm>
+            <a:off x="1645920" y="5907024"/>
+            <a:ext cx="1627632" cy="347472"/>
           </a:xfrm>
           <a:prstGeom prst="rect">
             <a:avLst/>
@@ -19397,28 +19704,48 @@
           </a:bodyPr>
           <a:lstStyle/>
           <a:p>
-            <a:pPr algn="ctr"/>
+            <a:pPr algn="ctr">
+              <a:lnSpc>
+                <a:spcPct val="90000"/>
+              </a:lnSpc>
+            </a:pPr>
             <a:r>
               <a:rPr sz="700" b="1" i="0">
                 <a:solidFill>
-                  <a:srgbClr val="0089A0"/>
-                </a:solidFill>
-                <a:latin typeface="Trenda IG Text"/>
-              </a:rPr>
-              <a:t>CAB</a:t>
+                  <a:srgbClr val="1A1A1A"/>
+                </a:solidFill>
+                <a:latin typeface="Trenda IG Text"/>
+              </a:rPr>
+              <a:t>Prompt in Codex</a:t>
+            </a:r>
+          </a:p>
+          <a:p>
+            <a:pPr algn="ctr">
+              <a:lnSpc>
+                <a:spcPct val="90000"/>
+              </a:lnSpc>
+            </a:pPr>
+            <a:r>
+              <a:rPr sz="700" b="0" i="0">
+                <a:solidFill>
+                  <a:srgbClr val="4D4D4D"/>
+                </a:solidFill>
+                <a:latin typeface="Trenda IG Text"/>
+              </a:rPr>
+              <a:t>Orchestrator</a:t>
             </a:r>
           </a:p>
         </p:txBody>
       </p:sp>
       <p:cxnSp>
         <p:nvCxnSpPr>
-          <p:cNvPr id="175" name="Arrow 166"/>
+          <p:cNvPr id="178" name="Arrow 169"/>
           <p:cNvCxnSpPr/>
           <p:nvPr/>
         </p:nvCxnSpPr>
         <p:spPr>
           <a:xfrm>
-            <a:off x="10643616" y="5705856"/>
+            <a:off x="3273552" y="6080760"/>
             <a:ext cx="73152" cy="0"/>
           </a:xfrm>
           <a:prstGeom prst="line">
@@ -19448,129 +19775,14 @@
       </p:cxnSp>
       <p:sp>
         <p:nvSpPr>
-          <p:cNvPr id="176" name="Shape 167"/>
-          <p:cNvSpPr/>
-          <p:nvPr/>
-        </p:nvSpPr>
-        <p:spPr>
-          <a:xfrm>
-            <a:off x="10716768" y="5559552"/>
-            <a:ext cx="1060704" cy="292608"/>
-          </a:xfrm>
-          <a:prstGeom prst="roundRect">
-            <a:avLst>
-              <a:gd name="adj" fmla="val 30000"/>
-            </a:avLst>
-          </a:prstGeom>
-          <a:solidFill>
-            <a:srgbClr val="F5F5F5"/>
-          </a:solidFill>
-          <a:ln w="11430">
-            <a:solidFill>
-              <a:srgbClr val="BDBDBD"/>
-            </a:solidFill>
-          </a:ln>
-          <a:effectLst/>
-        </p:spPr>
-        <p:style>
-          <a:lnRef idx="1">
-            <a:schemeClr val="accent1"/>
-          </a:lnRef>
-          <a:fillRef idx="3">
-            <a:schemeClr val="accent1"/>
-          </a:fillRef>
-          <a:effectRef idx="2">
-            <a:schemeClr val="accent1"/>
-          </a:effectRef>
-          <a:fontRef idx="minor">
-            <a:schemeClr val="lt1"/>
-          </a:fontRef>
-        </p:style>
-        <p:txBody>
-          <a:bodyPr rtlCol="0" anchor="ctr"/>
-          <a:lstStyle/>
-          <a:p/>
-        </p:txBody>
-      </p:sp>
-      <p:sp>
-        <p:nvSpPr>
-          <p:cNvPr id="177" name="Text 168"/>
-          <p:cNvSpPr txBox="1"/>
-          <p:nvPr/>
-        </p:nvSpPr>
-        <p:spPr>
-          <a:xfrm>
-            <a:off x="10716768" y="5559552"/>
-            <a:ext cx="1060704" cy="292608"/>
-          </a:xfrm>
-          <a:prstGeom prst="rect">
-            <a:avLst/>
-          </a:prstGeom>
-          <a:noFill/>
-        </p:spPr>
-        <p:txBody>
-          <a:bodyPr wrap="square" lIns="0" rIns="0" tIns="0" bIns="0" anchor="ctr">
-            <a:spAutoFit/>
-          </a:bodyPr>
-          <a:lstStyle/>
-          <a:p>
-            <a:pPr algn="ctr"/>
-            <a:r>
-              <a:rPr sz="700" b="0" i="0">
-                <a:solidFill>
-                  <a:srgbClr val="1A1A1A"/>
-                </a:solidFill>
-                <a:latin typeface="Trenda IG Text"/>
-              </a:rPr>
-              <a:t>PROD</a:t>
-            </a:r>
-          </a:p>
-        </p:txBody>
-      </p:sp>
-      <p:sp>
-        <p:nvSpPr>
-          <p:cNvPr id="178" name="Text 169"/>
-          <p:cNvSpPr txBox="1"/>
-          <p:nvPr/>
-        </p:nvSpPr>
-        <p:spPr>
-          <a:xfrm>
-            <a:off x="411480" y="5925312"/>
-            <a:ext cx="1188720" cy="292608"/>
-          </a:xfrm>
-          <a:prstGeom prst="rect">
-            <a:avLst/>
-          </a:prstGeom>
-          <a:noFill/>
-        </p:spPr>
-        <p:txBody>
-          <a:bodyPr wrap="square" lIns="0" rIns="0" tIns="0" bIns="0" anchor="ctr">
-            <a:spAutoFit/>
-          </a:bodyPr>
-          <a:lstStyle/>
-          <a:p>
-            <a:r>
-              <a:rPr sz="700" b="1" i="0" spc="120">
-                <a:solidFill>
-                  <a:srgbClr val="0089A0"/>
-                </a:solidFill>
-                <a:latin typeface="Trenda IG Text"/>
-              </a:rPr>
-              <a:t>CAMPAIGN PATH</a:t>
-            </a:r>
-          </a:p>
-        </p:txBody>
-      </p:sp>
-      <p:sp>
-        <p:nvSpPr>
           <p:cNvPr id="179" name="Shape 170"/>
           <p:cNvSpPr/>
           <p:nvPr/>
         </p:nvSpPr>
         <p:spPr>
           <a:xfrm>
-            <a:off x="1645920" y="5925312"/>
-            <a:ext cx="1627632" cy="292608"/>
+            <a:off x="3346704" y="5907024"/>
+            <a:ext cx="1627632" cy="347472"/>
           </a:xfrm>
           <a:prstGeom prst="roundRect">
             <a:avLst>
@@ -19615,8 +19827,8 @@
         </p:nvSpPr>
         <p:spPr>
           <a:xfrm>
-            <a:off x="1645920" y="5925312"/>
-            <a:ext cx="1627632" cy="292608"/>
+            <a:off x="3346704" y="5907024"/>
+            <a:ext cx="1627632" cy="347472"/>
           </a:xfrm>
           <a:prstGeom prst="rect">
             <a:avLst/>
@@ -19629,15 +19841,35 @@
           </a:bodyPr>
           <a:lstStyle/>
           <a:p>
-            <a:pPr algn="ctr"/>
+            <a:pPr algn="ctr">
+              <a:lnSpc>
+                <a:spcPct val="90000"/>
+              </a:lnSpc>
+            </a:pPr>
+            <a:r>
+              <a:rPr sz="700" b="1" i="0">
+                <a:solidFill>
+                  <a:srgbClr val="1A1A1A"/>
+                </a:solidFill>
+                <a:latin typeface="Trenda IG Text"/>
+              </a:rPr>
+              <a:t>Gold A insights</a:t>
+            </a:r>
+          </a:p>
+          <a:p>
+            <a:pPr algn="ctr">
+              <a:lnSpc>
+                <a:spcPct val="90000"/>
+              </a:lnSpc>
+            </a:pPr>
             <a:r>
               <a:rPr sz="700" b="0" i="0">
                 <a:solidFill>
-                  <a:srgbClr val="1A1A1A"/>
-                </a:solidFill>
-                <a:latin typeface="Trenda IG Text"/>
-              </a:rPr>
-              <a:t>Prompt in Codex</a:t>
+                  <a:srgbClr val="4D4D4D"/>
+                </a:solidFill>
+                <a:latin typeface="Trenda IG Text"/>
+              </a:rPr>
+              <a:t>Strategist + Analytics</a:t>
             </a:r>
           </a:p>
         </p:txBody>
@@ -19650,7 +19882,7 @@
         </p:nvCxnSpPr>
         <p:spPr>
           <a:xfrm>
-            <a:off x="3273552" y="6071616"/>
+            <a:off x="4974336" y="6080760"/>
             <a:ext cx="73152" cy="0"/>
           </a:xfrm>
           <a:prstGeom prst="line">
@@ -19686,8 +19918,8 @@
         </p:nvSpPr>
         <p:spPr>
           <a:xfrm>
-            <a:off x="3346704" y="5925312"/>
-            <a:ext cx="1627632" cy="292608"/>
+            <a:off x="5047488" y="5907024"/>
+            <a:ext cx="1627632" cy="347472"/>
           </a:xfrm>
           <a:prstGeom prst="roundRect">
             <a:avLst>
@@ -19732,8 +19964,8 @@
         </p:nvSpPr>
         <p:spPr>
           <a:xfrm>
-            <a:off x="3346704" y="5925312"/>
-            <a:ext cx="1627632" cy="292608"/>
+            <a:off x="5047488" y="5907024"/>
+            <a:ext cx="1627632" cy="347472"/>
           </a:xfrm>
           <a:prstGeom prst="rect">
             <a:avLst/>
@@ -19746,15 +19978,35 @@
           </a:bodyPr>
           <a:lstStyle/>
           <a:p>
-            <a:pPr algn="ctr"/>
+            <a:pPr algn="ctr">
+              <a:lnSpc>
+                <a:spcPct val="90000"/>
+              </a:lnSpc>
+            </a:pPr>
+            <a:r>
+              <a:rPr sz="700" b="1" i="0">
+                <a:solidFill>
+                  <a:srgbClr val="1A1A1A"/>
+                </a:solidFill>
+                <a:latin typeface="Trenda IG Text"/>
+              </a:rPr>
+              <a:t>Build + test</a:t>
+            </a:r>
+          </a:p>
+          <a:p>
+            <a:pPr algn="ctr">
+              <a:lnSpc>
+                <a:spcPct val="90000"/>
+              </a:lnSpc>
+            </a:pPr>
             <a:r>
               <a:rPr sz="700" b="0" i="0">
                 <a:solidFill>
-                  <a:srgbClr val="1A1A1A"/>
-                </a:solidFill>
-                <a:latin typeface="Trenda IG Text"/>
-              </a:rPr>
-              <a:t>Gold A insights</a:t>
+                  <a:srgbClr val="4D4D4D"/>
+                </a:solidFill>
+                <a:latin typeface="Trenda IG Text"/>
+              </a:rPr>
+              <a:t>Design + Readiness</a:t>
             </a:r>
           </a:p>
         </p:txBody>
@@ -19767,7 +20019,7 @@
         </p:nvCxnSpPr>
         <p:spPr>
           <a:xfrm>
-            <a:off x="4974336" y="6071616"/>
+            <a:off x="6675120" y="6080760"/>
             <a:ext cx="73152" cy="0"/>
           </a:xfrm>
           <a:prstGeom prst="line">
@@ -19803,8 +20055,8 @@
         </p:nvSpPr>
         <p:spPr>
           <a:xfrm>
-            <a:off x="5047488" y="5925312"/>
-            <a:ext cx="1627632" cy="292608"/>
+            <a:off x="6748272" y="5907024"/>
+            <a:ext cx="1627632" cy="347472"/>
           </a:xfrm>
           <a:prstGeom prst="roundRect">
             <a:avLst>
@@ -19849,8 +20101,8 @@
         </p:nvSpPr>
         <p:spPr>
           <a:xfrm>
-            <a:off x="5047488" y="5925312"/>
-            <a:ext cx="1627632" cy="292608"/>
+            <a:off x="6748272" y="5907024"/>
+            <a:ext cx="1627632" cy="347472"/>
           </a:xfrm>
           <a:prstGeom prst="rect">
             <a:avLst/>
@@ -19863,15 +20115,35 @@
           </a:bodyPr>
           <a:lstStyle/>
           <a:p>
-            <a:pPr algn="ctr"/>
+            <a:pPr algn="ctr">
+              <a:lnSpc>
+                <a:spcPct val="90000"/>
+              </a:lnSpc>
+            </a:pPr>
+            <a:r>
+              <a:rPr sz="700" b="1" i="0">
+                <a:solidFill>
+                  <a:srgbClr val="0089A0"/>
+                </a:solidFill>
+                <a:latin typeface="Trenda IG Text"/>
+              </a:rPr>
+              <a:t>Pre-send review</a:t>
+            </a:r>
+          </a:p>
+          <a:p>
+            <a:pPr algn="ctr">
+              <a:lnSpc>
+                <a:spcPct val="90000"/>
+              </a:lnSpc>
+            </a:pPr>
             <a:r>
               <a:rPr sz="700" b="0" i="0">
                 <a:solidFill>
-                  <a:srgbClr val="1A1A1A"/>
-                </a:solidFill>
-                <a:latin typeface="Trenda IG Text"/>
-              </a:rPr>
-              <a:t>Build + test</a:t>
+                  <a:srgbClr val="0089A0"/>
+                </a:solidFill>
+                <a:latin typeface="Trenda IG Text"/>
+              </a:rPr>
+              <a:t>SME + tech lead</a:t>
             </a:r>
           </a:p>
         </p:txBody>
@@ -19884,7 +20156,7 @@
         </p:nvCxnSpPr>
         <p:spPr>
           <a:xfrm>
-            <a:off x="6675120" y="6071616"/>
+            <a:off x="8375904" y="6080760"/>
             <a:ext cx="73152" cy="0"/>
           </a:xfrm>
           <a:prstGeom prst="line">
@@ -19920,8 +20192,8 @@
         </p:nvSpPr>
         <p:spPr>
           <a:xfrm>
-            <a:off x="6748272" y="5925312"/>
-            <a:ext cx="1627632" cy="292608"/>
+            <a:off x="8449056" y="5907024"/>
+            <a:ext cx="1627632" cy="347472"/>
           </a:xfrm>
           <a:prstGeom prst="roundRect">
             <a:avLst>
@@ -19966,8 +20238,8 @@
         </p:nvSpPr>
         <p:spPr>
           <a:xfrm>
-            <a:off x="6748272" y="5925312"/>
-            <a:ext cx="1627632" cy="292608"/>
+            <a:off x="8449056" y="5907024"/>
+            <a:ext cx="1627632" cy="347472"/>
           </a:xfrm>
           <a:prstGeom prst="rect">
             <a:avLst/>
@@ -19980,15 +20252,35 @@
           </a:bodyPr>
           <a:lstStyle/>
           <a:p>
-            <a:pPr algn="ctr"/>
+            <a:pPr algn="ctr">
+              <a:lnSpc>
+                <a:spcPct val="90000"/>
+              </a:lnSpc>
+            </a:pPr>
             <a:r>
               <a:rPr sz="700" b="1" i="0">
                 <a:solidFill>
-                  <a:srgbClr val="0089A0"/>
-                </a:solidFill>
-                <a:latin typeface="Trenda IG Text"/>
-              </a:rPr>
-              <a:t>Pre-send review</a:t>
+                  <a:srgbClr val="1A1A1A"/>
+                </a:solidFill>
+                <a:latin typeface="Trenda IG Text"/>
+              </a:rPr>
+              <a:t>Gateway release</a:t>
+            </a:r>
+          </a:p>
+          <a:p>
+            <a:pPr algn="ctr">
+              <a:lnSpc>
+                <a:spcPct val="90000"/>
+              </a:lnSpc>
+            </a:pPr>
+            <a:r>
+              <a:rPr sz="700" b="0" i="0">
+                <a:solidFill>
+                  <a:srgbClr val="4D4D4D"/>
+                </a:solidFill>
+                <a:latin typeface="Trenda IG Text"/>
+              </a:rPr>
+              <a:t>policy service</a:t>
             </a:r>
           </a:p>
         </p:txBody>
@@ -20001,7 +20293,7 @@
         </p:nvCxnSpPr>
         <p:spPr>
           <a:xfrm>
-            <a:off x="8375904" y="6071616"/>
+            <a:off x="10076688" y="6080760"/>
             <a:ext cx="73152" cy="0"/>
           </a:xfrm>
           <a:prstGeom prst="line">
@@ -20037,8 +20329,8 @@
         </p:nvSpPr>
         <p:spPr>
           <a:xfrm>
-            <a:off x="8449056" y="5925312"/>
-            <a:ext cx="1627632" cy="292608"/>
+            <a:off x="10149840" y="5907024"/>
+            <a:ext cx="1627632" cy="347472"/>
           </a:xfrm>
           <a:prstGeom prst="roundRect">
             <a:avLst>
@@ -20083,8 +20375,8 @@
         </p:nvSpPr>
         <p:spPr>
           <a:xfrm>
-            <a:off x="8449056" y="5925312"/>
-            <a:ext cx="1627632" cy="292608"/>
+            <a:off x="10149840" y="5907024"/>
+            <a:ext cx="1627632" cy="347472"/>
           </a:xfrm>
           <a:prstGeom prst="rect">
             <a:avLst/>
@@ -20097,132 +20389,35 @@
           </a:bodyPr>
           <a:lstStyle/>
           <a:p>
-            <a:pPr algn="ctr"/>
+            <a:pPr algn="ctr">
+              <a:lnSpc>
+                <a:spcPct val="90000"/>
+              </a:lnSpc>
+            </a:pPr>
+            <a:r>
+              <a:rPr sz="700" b="1" i="0">
+                <a:solidFill>
+                  <a:srgbClr val="1A1A1A"/>
+                </a:solidFill>
+                <a:latin typeface="Trenda IG Text"/>
+              </a:rPr>
+              <a:t>Journey runs</a:t>
+            </a:r>
+          </a:p>
+          <a:p>
+            <a:pPr algn="ctr">
+              <a:lnSpc>
+                <a:spcPct val="90000"/>
+              </a:lnSpc>
+            </a:pPr>
             <a:r>
               <a:rPr sz="700" b="0" i="0">
                 <a:solidFill>
-                  <a:srgbClr val="1A1A1A"/>
-                </a:solidFill>
-                <a:latin typeface="Trenda IG Text"/>
-              </a:rPr>
-              <a:t>Gateway release</a:t>
-            </a:r>
-          </a:p>
-        </p:txBody>
-      </p:sp>
-      <p:cxnSp>
-        <p:nvCxnSpPr>
-          <p:cNvPr id="193" name="Arrow 184"/>
-          <p:cNvCxnSpPr/>
-          <p:nvPr/>
-        </p:nvCxnSpPr>
-        <p:spPr>
-          <a:xfrm>
-            <a:off x="10076688" y="6071616"/>
-            <a:ext cx="73152" cy="0"/>
-          </a:xfrm>
-          <a:prstGeom prst="line">
-            <a:avLst/>
-          </a:prstGeom>
-          <a:ln w="9525">
-            <a:solidFill>
-              <a:srgbClr val="8C8C8C"/>
-            </a:solidFill>
-            <a:tailEnd type="triangle" w="med" len="med"/>
-          </a:ln>
-        </p:spPr>
-        <p:style>
-          <a:lnRef idx="2">
-            <a:schemeClr val="accent1"/>
-          </a:lnRef>
-          <a:fillRef idx="0">
-            <a:schemeClr val="accent1"/>
-          </a:fillRef>
-          <a:effectRef idx="1">
-            <a:schemeClr val="accent1"/>
-          </a:effectRef>
-          <a:fontRef idx="minor">
-            <a:schemeClr val="tx1"/>
-          </a:fontRef>
-        </p:style>
-      </p:cxnSp>
-      <p:sp>
-        <p:nvSpPr>
-          <p:cNvPr id="194" name="Shape 185"/>
-          <p:cNvSpPr/>
-          <p:nvPr/>
-        </p:nvSpPr>
-        <p:spPr>
-          <a:xfrm>
-            <a:off x="10149840" y="5925312"/>
-            <a:ext cx="1627632" cy="292608"/>
-          </a:xfrm>
-          <a:prstGeom prst="roundRect">
-            <a:avLst>
-              <a:gd name="adj" fmla="val 30000"/>
-            </a:avLst>
-          </a:prstGeom>
-          <a:solidFill>
-            <a:srgbClr val="F5F5F5"/>
-          </a:solidFill>
-          <a:ln w="11430">
-            <a:solidFill>
-              <a:srgbClr val="00B8D4"/>
-            </a:solidFill>
-          </a:ln>
-          <a:effectLst/>
-        </p:spPr>
-        <p:style>
-          <a:lnRef idx="1">
-            <a:schemeClr val="accent1"/>
-          </a:lnRef>
-          <a:fillRef idx="3">
-            <a:schemeClr val="accent1"/>
-          </a:fillRef>
-          <a:effectRef idx="2">
-            <a:schemeClr val="accent1"/>
-          </a:effectRef>
-          <a:fontRef idx="minor">
-            <a:schemeClr val="lt1"/>
-          </a:fontRef>
-        </p:style>
-        <p:txBody>
-          <a:bodyPr rtlCol="0" anchor="ctr"/>
-          <a:lstStyle/>
-          <a:p/>
-        </p:txBody>
-      </p:sp>
-      <p:sp>
-        <p:nvSpPr>
-          <p:cNvPr id="195" name="Text 186"/>
-          <p:cNvSpPr txBox="1"/>
-          <p:nvPr/>
-        </p:nvSpPr>
-        <p:spPr>
-          <a:xfrm>
-            <a:off x="10149840" y="5925312"/>
-            <a:ext cx="1627632" cy="292608"/>
-          </a:xfrm>
-          <a:prstGeom prst="rect">
-            <a:avLst/>
-          </a:prstGeom>
-          <a:noFill/>
-        </p:spPr>
-        <p:txBody>
-          <a:bodyPr wrap="square" lIns="0" rIns="0" tIns="0" bIns="0" anchor="ctr">
-            <a:spAutoFit/>
-          </a:bodyPr>
-          <a:lstStyle/>
-          <a:p>
-            <a:pPr algn="ctr"/>
-            <a:r>
-              <a:rPr sz="700" b="0" i="0">
-                <a:solidFill>
-                  <a:srgbClr val="1A1A1A"/>
-                </a:solidFill>
-                <a:latin typeface="Trenda IG Text"/>
-              </a:rPr>
-              <a:t>Journey runs</a:t>
+                  <a:srgbClr val="4D4D4D"/>
+                </a:solidFill>
+                <a:latin typeface="Trenda IG Text"/>
+              </a:rPr>
+              <a:t>Marketing Cloud</a:t>
             </a:r>
           </a:p>
         </p:txBody>
@@ -23404,9 +23599,9 @@
           <a:lstStyle/>
           <a:p>
             <a:r>
-              <a:rPr sz="740" b="1" i="0">
-                <a:solidFill>
-                  <a:srgbClr val="1A1A1A"/>
+              <a:rPr sz="860" b="1" i="0">
+                <a:solidFill>
+                  <a:srgbClr val="8A6D00"/>
                 </a:solidFill>
                 <a:latin typeface="Trenda IG Text"/>
               </a:rPr>
@@ -23417,116 +23612,14 @@
       </p:sp>
       <p:sp>
         <p:nvSpPr>
-          <p:cNvPr id="88" name="Text 81"/>
-          <p:cNvSpPr txBox="1"/>
-          <p:nvPr/>
-        </p:nvSpPr>
-        <p:spPr>
-          <a:xfrm>
-            <a:off x="6528816" y="2688336"/>
-            <a:ext cx="1691640" cy="310896"/>
-          </a:xfrm>
-          <a:prstGeom prst="rect">
-            <a:avLst/>
-          </a:prstGeom>
-          <a:noFill/>
-        </p:spPr>
-        <p:txBody>
-          <a:bodyPr wrap="square" lIns="0" rIns="0" tIns="0" bIns="0" anchor="ctr">
-            <a:spAutoFit/>
-          </a:bodyPr>
-          <a:lstStyle/>
-          <a:p>
-            <a:r>
-              <a:rPr sz="740" b="1" i="0">
-                <a:solidFill>
-                  <a:srgbClr val="1A1A1A"/>
-                </a:solidFill>
-                <a:latin typeface="Trenda IG Text"/>
-              </a:rPr>
-              <a:t>Guardrails in + out · Model Armor</a:t>
-            </a:r>
-          </a:p>
-        </p:txBody>
-      </p:sp>
-      <p:sp>
-        <p:nvSpPr>
-          <p:cNvPr id="89" name="Text 82"/>
-          <p:cNvSpPr txBox="1"/>
-          <p:nvPr/>
-        </p:nvSpPr>
-        <p:spPr>
-          <a:xfrm>
-            <a:off x="6528816" y="3035808"/>
-            <a:ext cx="1691640" cy="310896"/>
-          </a:xfrm>
-          <a:prstGeom prst="rect">
-            <a:avLst/>
-          </a:prstGeom>
-          <a:noFill/>
-        </p:spPr>
-        <p:txBody>
-          <a:bodyPr wrap="square" lIns="0" rIns="0" tIns="0" bIns="0" anchor="ctr">
-            <a:spAutoFit/>
-          </a:bodyPr>
-          <a:lstStyle/>
-          <a:p>
-            <a:r>
-              <a:rPr sz="740" b="1" i="0">
-                <a:solidFill>
-                  <a:srgbClr val="1A1A1A"/>
-                </a:solidFill>
-                <a:latin typeface="Trenda IG Text"/>
-              </a:rPr>
-              <a:t>Identity + access</a:t>
-            </a:r>
-          </a:p>
-        </p:txBody>
-      </p:sp>
-      <p:sp>
-        <p:nvSpPr>
-          <p:cNvPr id="90" name="Text 83"/>
-          <p:cNvSpPr txBox="1"/>
-          <p:nvPr/>
-        </p:nvSpPr>
-        <p:spPr>
-          <a:xfrm>
-            <a:off x="6528816" y="3383279"/>
-            <a:ext cx="1691640" cy="310896"/>
-          </a:xfrm>
-          <a:prstGeom prst="rect">
-            <a:avLst/>
-          </a:prstGeom>
-          <a:noFill/>
-        </p:spPr>
-        <p:txBody>
-          <a:bodyPr wrap="square" lIns="0" rIns="0" tIns="0" bIns="0" anchor="ctr">
-            <a:spAutoFit/>
-          </a:bodyPr>
-          <a:lstStyle/>
-          <a:p>
-            <a:r>
-              <a:rPr sz="740" b="1" i="0">
-                <a:solidFill>
-                  <a:srgbClr val="1A1A1A"/>
-                </a:solidFill>
-                <a:latin typeface="Trenda IG Text"/>
-              </a:rPr>
-              <a:t>Collibra masking + DLP</a:t>
-            </a:r>
-          </a:p>
-        </p:txBody>
-      </p:sp>
-      <p:sp>
-        <p:nvSpPr>
-          <p:cNvPr id="91" name="Shape 84"/>
+          <p:cNvPr id="88" name="Shape 81"/>
           <p:cNvSpPr/>
           <p:nvPr/>
         </p:nvSpPr>
         <p:spPr>
           <a:xfrm>
-            <a:off x="8202167" y="3474720"/>
-            <a:ext cx="329184" cy="137160"/>
+            <a:off x="7854696" y="2423160"/>
+            <a:ext cx="694944" cy="155448"/>
           </a:xfrm>
           <a:prstGeom prst="roundRect">
             <a:avLst>
@@ -23565,82 +23658,150 @@
       </p:sp>
       <p:sp>
         <p:nvSpPr>
+          <p:cNvPr id="89" name="Text 82"/>
+          <p:cNvSpPr txBox="1"/>
+          <p:nvPr/>
+        </p:nvSpPr>
+        <p:spPr>
+          <a:xfrm>
+            <a:off x="7854696" y="2423160"/>
+            <a:ext cx="694944" cy="155448"/>
+          </a:xfrm>
+          <a:prstGeom prst="rect">
+            <a:avLst/>
+          </a:prstGeom>
+          <a:noFill/>
+        </p:spPr>
+        <p:txBody>
+          <a:bodyPr wrap="square" lIns="0" rIns="0" tIns="0" bIns="0" anchor="ctr">
+            <a:spAutoFit/>
+          </a:bodyPr>
+          <a:lstStyle/>
+          <a:p>
+            <a:pPr algn="ctr"/>
+            <a:r>
+              <a:rPr sz="700" b="1" i="0" spc="80">
+                <a:solidFill>
+                  <a:srgbClr val="1A1A1A"/>
+                </a:solidFill>
+                <a:latin typeface="Trenda IG Text"/>
+              </a:rPr>
+              <a:t>WE BUILD IT</a:t>
+            </a:r>
+          </a:p>
+        </p:txBody>
+      </p:sp>
+      <p:sp>
+        <p:nvSpPr>
+          <p:cNvPr id="90" name="Text 83"/>
+          <p:cNvSpPr txBox="1"/>
+          <p:nvPr/>
+        </p:nvSpPr>
+        <p:spPr>
+          <a:xfrm>
+            <a:off x="6528816" y="2688336"/>
+            <a:ext cx="1691640" cy="310896"/>
+          </a:xfrm>
+          <a:prstGeom prst="rect">
+            <a:avLst/>
+          </a:prstGeom>
+          <a:noFill/>
+        </p:spPr>
+        <p:txBody>
+          <a:bodyPr wrap="square" lIns="0" rIns="0" tIns="0" bIns="0" anchor="ctr">
+            <a:spAutoFit/>
+          </a:bodyPr>
+          <a:lstStyle/>
+          <a:p>
+            <a:r>
+              <a:rPr sz="740" b="1" i="0">
+                <a:solidFill>
+                  <a:srgbClr val="1A1A1A"/>
+                </a:solidFill>
+                <a:latin typeface="Trenda IG Text"/>
+              </a:rPr>
+              <a:t>Guardrails in + out · Model Armor</a:t>
+            </a:r>
+          </a:p>
+        </p:txBody>
+      </p:sp>
+      <p:sp>
+        <p:nvSpPr>
+          <p:cNvPr id="91" name="Text 84"/>
+          <p:cNvSpPr txBox="1"/>
+          <p:nvPr/>
+        </p:nvSpPr>
+        <p:spPr>
+          <a:xfrm>
+            <a:off x="6528816" y="3035808"/>
+            <a:ext cx="1691640" cy="310896"/>
+          </a:xfrm>
+          <a:prstGeom prst="rect">
+            <a:avLst/>
+          </a:prstGeom>
+          <a:noFill/>
+        </p:spPr>
+        <p:txBody>
+          <a:bodyPr wrap="square" lIns="0" rIns="0" tIns="0" bIns="0" anchor="ctr">
+            <a:spAutoFit/>
+          </a:bodyPr>
+          <a:lstStyle/>
+          <a:p>
+            <a:r>
+              <a:rPr sz="740" b="1" i="0">
+                <a:solidFill>
+                  <a:srgbClr val="1A1A1A"/>
+                </a:solidFill>
+                <a:latin typeface="Trenda IG Text"/>
+              </a:rPr>
+              <a:t>Identity + access</a:t>
+            </a:r>
+          </a:p>
+        </p:txBody>
+      </p:sp>
+      <p:sp>
+        <p:nvSpPr>
           <p:cNvPr id="92" name="Text 85"/>
           <p:cNvSpPr txBox="1"/>
           <p:nvPr/>
         </p:nvSpPr>
         <p:spPr>
           <a:xfrm>
+            <a:off x="6528816" y="3383279"/>
+            <a:ext cx="1691640" cy="310896"/>
+          </a:xfrm>
+          <a:prstGeom prst="rect">
+            <a:avLst/>
+          </a:prstGeom>
+          <a:noFill/>
+        </p:spPr>
+        <p:txBody>
+          <a:bodyPr wrap="square" lIns="0" rIns="0" tIns="0" bIns="0" anchor="ctr">
+            <a:spAutoFit/>
+          </a:bodyPr>
+          <a:lstStyle/>
+          <a:p>
+            <a:r>
+              <a:rPr sz="740" b="1" i="0">
+                <a:solidFill>
+                  <a:srgbClr val="1A1A1A"/>
+                </a:solidFill>
+                <a:latin typeface="Trenda IG Text"/>
+              </a:rPr>
+              <a:t>Collibra masking + DLP</a:t>
+            </a:r>
+          </a:p>
+        </p:txBody>
+      </p:sp>
+      <p:sp>
+        <p:nvSpPr>
+          <p:cNvPr id="93" name="Shape 86"/>
+          <p:cNvSpPr/>
+          <p:nvPr/>
+        </p:nvSpPr>
+        <p:spPr>
+          <a:xfrm>
             <a:off x="8202167" y="3474720"/>
-            <a:ext cx="329184" cy="137160"/>
-          </a:xfrm>
-          <a:prstGeom prst="rect">
-            <a:avLst/>
-          </a:prstGeom>
-          <a:noFill/>
-        </p:spPr>
-        <p:txBody>
-          <a:bodyPr wrap="square" lIns="0" rIns="0" tIns="0" bIns="0" anchor="ctr">
-            <a:spAutoFit/>
-          </a:bodyPr>
-          <a:lstStyle/>
-          <a:p>
-            <a:pPr algn="ctr"/>
-            <a:r>
-              <a:rPr sz="700" b="1" i="0" spc="80">
-                <a:solidFill>
-                  <a:srgbClr val="1A1A1A"/>
-                </a:solidFill>
-                <a:latin typeface="Trenda IG Text"/>
-              </a:rPr>
-              <a:t>NEW</a:t>
-            </a:r>
-          </a:p>
-        </p:txBody>
-      </p:sp>
-      <p:sp>
-        <p:nvSpPr>
-          <p:cNvPr id="93" name="Text 86"/>
-          <p:cNvSpPr txBox="1"/>
-          <p:nvPr/>
-        </p:nvSpPr>
-        <p:spPr>
-          <a:xfrm>
-            <a:off x="6528816" y="3730752"/>
-            <a:ext cx="1691640" cy="310896"/>
-          </a:xfrm>
-          <a:prstGeom prst="rect">
-            <a:avLst/>
-          </a:prstGeom>
-          <a:noFill/>
-        </p:spPr>
-        <p:txBody>
-          <a:bodyPr wrap="square" lIns="0" rIns="0" tIns="0" bIns="0" anchor="ctr">
-            <a:spAutoFit/>
-          </a:bodyPr>
-          <a:lstStyle/>
-          <a:p>
-            <a:r>
-              <a:rPr sz="740" b="1" i="0">
-                <a:solidFill>
-                  <a:srgbClr val="1A1A1A"/>
-                </a:solidFill>
-                <a:latin typeface="Trenda IG Text"/>
-              </a:rPr>
-              <a:t>Compliance Guardian + policy engine</a:t>
-            </a:r>
-          </a:p>
-        </p:txBody>
-      </p:sp>
-      <p:sp>
-        <p:nvSpPr>
-          <p:cNvPr id="94" name="Shape 87"/>
-          <p:cNvSpPr/>
-          <p:nvPr/>
-        </p:nvSpPr>
-        <p:spPr>
-          <a:xfrm>
-            <a:off x="8202167" y="3822191"/>
             <a:ext cx="329184" cy="137160"/>
           </a:xfrm>
           <a:prstGeom prst="roundRect">
@@ -23680,8 +23841,77 @@
       </p:sp>
       <p:sp>
         <p:nvSpPr>
+          <p:cNvPr id="94" name="Text 87"/>
+          <p:cNvSpPr txBox="1"/>
+          <p:nvPr/>
+        </p:nvSpPr>
+        <p:spPr>
+          <a:xfrm>
+            <a:off x="8202167" y="3474720"/>
+            <a:ext cx="329184" cy="137160"/>
+          </a:xfrm>
+          <a:prstGeom prst="rect">
+            <a:avLst/>
+          </a:prstGeom>
+          <a:noFill/>
+        </p:spPr>
+        <p:txBody>
+          <a:bodyPr wrap="square" lIns="0" rIns="0" tIns="0" bIns="0" anchor="ctr">
+            <a:spAutoFit/>
+          </a:bodyPr>
+          <a:lstStyle/>
+          <a:p>
+            <a:pPr algn="ctr"/>
+            <a:r>
+              <a:rPr sz="700" b="1" i="0" spc="80">
+                <a:solidFill>
+                  <a:srgbClr val="1A1A1A"/>
+                </a:solidFill>
+                <a:latin typeface="Trenda IG Text"/>
+              </a:rPr>
+              <a:t>NEW</a:t>
+            </a:r>
+          </a:p>
+        </p:txBody>
+      </p:sp>
+      <p:sp>
+        <p:nvSpPr>
           <p:cNvPr id="95" name="Text 88"/>
           <p:cNvSpPr txBox="1"/>
+          <p:nvPr/>
+        </p:nvSpPr>
+        <p:spPr>
+          <a:xfrm>
+            <a:off x="6528816" y="3730752"/>
+            <a:ext cx="1691640" cy="310896"/>
+          </a:xfrm>
+          <a:prstGeom prst="rect">
+            <a:avLst/>
+          </a:prstGeom>
+          <a:noFill/>
+        </p:spPr>
+        <p:txBody>
+          <a:bodyPr wrap="square" lIns="0" rIns="0" tIns="0" bIns="0" anchor="ctr">
+            <a:spAutoFit/>
+          </a:bodyPr>
+          <a:lstStyle/>
+          <a:p>
+            <a:r>
+              <a:rPr sz="740" b="1" i="0">
+                <a:solidFill>
+                  <a:srgbClr val="1A1A1A"/>
+                </a:solidFill>
+                <a:latin typeface="Trenda IG Text"/>
+              </a:rPr>
+              <a:t>Compliance Guardian + policy engine</a:t>
+            </a:r>
+          </a:p>
+        </p:txBody>
+      </p:sp>
+      <p:sp>
+        <p:nvSpPr>
+          <p:cNvPr id="96" name="Shape 89"/>
+          <p:cNvSpPr/>
           <p:nvPr/>
         </p:nvSpPr>
         <p:spPr>
@@ -23689,6 +23919,52 @@
             <a:off x="8202167" y="3822191"/>
             <a:ext cx="329184" cy="137160"/>
           </a:xfrm>
+          <a:prstGeom prst="roundRect">
+            <a:avLst>
+              <a:gd name="adj" fmla="val 50000"/>
+            </a:avLst>
+          </a:prstGeom>
+          <a:solidFill>
+            <a:srgbClr val="FFD700"/>
+          </a:solidFill>
+          <a:ln w="6350">
+            <a:solidFill>
+              <a:srgbClr val="C9A100"/>
+            </a:solidFill>
+          </a:ln>
+          <a:effectLst/>
+        </p:spPr>
+        <p:style>
+          <a:lnRef idx="1">
+            <a:schemeClr val="accent1"/>
+          </a:lnRef>
+          <a:fillRef idx="3">
+            <a:schemeClr val="accent1"/>
+          </a:fillRef>
+          <a:effectRef idx="2">
+            <a:schemeClr val="accent1"/>
+          </a:effectRef>
+          <a:fontRef idx="minor">
+            <a:schemeClr val="lt1"/>
+          </a:fontRef>
+        </p:style>
+        <p:txBody>
+          <a:bodyPr rtlCol="0" anchor="ctr"/>
+          <a:lstStyle/>
+          <a:p/>
+        </p:txBody>
+      </p:sp>
+      <p:sp>
+        <p:nvSpPr>
+          <p:cNvPr id="97" name="Text 90"/>
+          <p:cNvSpPr txBox="1"/>
+          <p:nvPr/>
+        </p:nvSpPr>
+        <p:spPr>
+          <a:xfrm>
+            <a:off x="8202167" y="3822191"/>
+            <a:ext cx="329184" cy="137160"/>
+          </a:xfrm>
           <a:prstGeom prst="rect">
             <a:avLst/>
           </a:prstGeom>
@@ -23715,7 +23991,7 @@
       </p:sp>
       <p:sp>
         <p:nvSpPr>
-          <p:cNvPr id="96" name="Text 89"/>
+          <p:cNvPr id="98" name="Text 91"/>
           <p:cNvSpPr txBox="1"/>
           <p:nvPr/>
         </p:nvSpPr>
@@ -23749,7 +24025,7 @@
       </p:sp>
       <p:sp>
         <p:nvSpPr>
-          <p:cNvPr id="97" name="Text 90"/>
+          <p:cNvPr id="99" name="Text 92"/>
           <p:cNvSpPr txBox="1"/>
           <p:nvPr/>
         </p:nvSpPr>
@@ -23783,7 +24059,7 @@
       </p:sp>
       <p:sp>
         <p:nvSpPr>
-          <p:cNvPr id="98" name="Text 91"/>
+          <p:cNvPr id="100" name="Text 93"/>
           <p:cNvSpPr txBox="1"/>
           <p:nvPr/>
         </p:nvSpPr>
@@ -23817,7 +24093,7 @@
       </p:sp>
       <p:sp>
         <p:nvSpPr>
-          <p:cNvPr id="99" name="Text 92"/>
+          <p:cNvPr id="101" name="Text 94"/>
           <p:cNvSpPr txBox="1"/>
           <p:nvPr/>
         </p:nvSpPr>
@@ -23851,7 +24127,7 @@
       </p:sp>
       <p:sp>
         <p:nvSpPr>
-          <p:cNvPr id="100" name="Shape 93"/>
+          <p:cNvPr id="102" name="Shape 95"/>
           <p:cNvSpPr/>
           <p:nvPr/>
         </p:nvSpPr>
@@ -23901,7 +24177,7 @@
       </p:sp>
       <p:sp>
         <p:nvSpPr>
-          <p:cNvPr id="100" name="Shape 93"/>
+          <p:cNvPr id="102" name="Shape 95"/>
           <p:cNvSpPr/>
           <p:nvPr/>
         </p:nvSpPr>
@@ -23945,7 +24221,7 @@
       </p:sp>
       <p:sp>
         <p:nvSpPr>
-          <p:cNvPr id="101" name="Shape 94"/>
+          <p:cNvPr id="103" name="Shape 96"/>
           <p:cNvSpPr/>
           <p:nvPr/>
         </p:nvSpPr>
@@ -23987,7 +24263,7 @@
       </p:sp>
       <p:sp>
         <p:nvSpPr>
-          <p:cNvPr id="102" name="Text 95"/>
+          <p:cNvPr id="104" name="Text 97"/>
           <p:cNvSpPr txBox="1"/>
           <p:nvPr/>
         </p:nvSpPr>
@@ -24022,7 +24298,7 @@
       </p:sp>
       <p:sp>
         <p:nvSpPr>
-          <p:cNvPr id="103" name="Text 96"/>
+          <p:cNvPr id="105" name="Text 98"/>
           <p:cNvSpPr txBox="1"/>
           <p:nvPr/>
         </p:nvSpPr>
@@ -24056,7 +24332,7 @@
       </p:sp>
       <p:sp>
         <p:nvSpPr>
-          <p:cNvPr id="104" name="Text 97"/>
+          <p:cNvPr id="106" name="Text 99"/>
           <p:cNvSpPr txBox="1"/>
           <p:nvPr/>
         </p:nvSpPr>
@@ -24090,7 +24366,7 @@
       </p:sp>
       <p:sp>
         <p:nvSpPr>
-          <p:cNvPr id="105" name="Text 98"/>
+          <p:cNvPr id="107" name="Text 100"/>
           <p:cNvSpPr txBox="1"/>
           <p:nvPr/>
         </p:nvSpPr>
@@ -24124,7 +24400,7 @@
       </p:sp>
       <p:sp>
         <p:nvSpPr>
-          <p:cNvPr id="106" name="Shape 99"/>
+          <p:cNvPr id="108" name="Shape 101"/>
           <p:cNvSpPr/>
           <p:nvPr/>
         </p:nvSpPr>
@@ -24174,7 +24450,7 @@
       </p:sp>
       <p:sp>
         <p:nvSpPr>
-          <p:cNvPr id="106" name="Shape 99"/>
+          <p:cNvPr id="108" name="Shape 101"/>
           <p:cNvSpPr/>
           <p:nvPr/>
         </p:nvSpPr>
@@ -24218,7 +24494,7 @@
       </p:sp>
       <p:sp>
         <p:nvSpPr>
-          <p:cNvPr id="107" name="Shape 100"/>
+          <p:cNvPr id="109" name="Shape 102"/>
           <p:cNvSpPr/>
           <p:nvPr/>
         </p:nvSpPr>
@@ -24260,7 +24536,7 @@
       </p:sp>
       <p:sp>
         <p:nvSpPr>
-          <p:cNvPr id="108" name="Text 101"/>
+          <p:cNvPr id="110" name="Text 103"/>
           <p:cNvSpPr txBox="1"/>
           <p:nvPr/>
         </p:nvSpPr>
@@ -24295,7 +24571,7 @@
       </p:sp>
       <p:sp>
         <p:nvSpPr>
-          <p:cNvPr id="109" name="Text 102"/>
+          <p:cNvPr id="111" name="Text 104"/>
           <p:cNvSpPr txBox="1"/>
           <p:nvPr/>
         </p:nvSpPr>
@@ -24329,7 +24605,7 @@
       </p:sp>
       <p:sp>
         <p:nvSpPr>
-          <p:cNvPr id="110" name="Text 103"/>
+          <p:cNvPr id="112" name="Text 105"/>
           <p:cNvSpPr txBox="1"/>
           <p:nvPr/>
         </p:nvSpPr>
@@ -24356,14 +24632,32 @@
                 </a:solidFill>
                 <a:latin typeface="Trenda IG Text"/>
               </a:rPr>
-              <a:t>The Change Guardian checks every change against who owns and uses it.</a:t>
-            </a:r>
-          </a:p>
-        </p:txBody>
-      </p:sp>
-      <p:sp>
-        <p:nvSpPr>
-          <p:cNvPr id="111" name="Text 104"/>
+              <a:t>The </a:t>
+            </a:r>
+            <a:r>
+              <a:rPr sz="700" b="1" i="0">
+                <a:solidFill>
+                  <a:srgbClr val="8A6D00"/>
+                </a:solidFill>
+                <a:latin typeface="Trenda IG Text"/>
+              </a:rPr>
+              <a:t>Change Guardian</a:t>
+            </a:r>
+            <a:r>
+              <a:rPr sz="700" b="0" i="0">
+                <a:solidFill>
+                  <a:srgbClr val="4D4D4D"/>
+                </a:solidFill>
+                <a:latin typeface="Trenda IG Text"/>
+              </a:rPr>
+              <a:t> checks every change against who owns and uses it.</a:t>
+            </a:r>
+          </a:p>
+        </p:txBody>
+      </p:sp>
+      <p:sp>
+        <p:nvSpPr>
+          <p:cNvPr id="113" name="Text 106"/>
           <p:cNvSpPr txBox="1"/>
           <p:nvPr/>
         </p:nvSpPr>
@@ -24397,7 +24691,7 @@
       </p:sp>
       <p:sp>
         <p:nvSpPr>
-          <p:cNvPr id="112" name="Shape 105"/>
+          <p:cNvPr id="114" name="Shape 107"/>
           <p:cNvSpPr/>
           <p:nvPr/>
         </p:nvSpPr>
@@ -24447,7 +24741,7 @@
       </p:sp>
       <p:sp>
         <p:nvSpPr>
-          <p:cNvPr id="112" name="Shape 105"/>
+          <p:cNvPr id="114" name="Shape 107"/>
           <p:cNvSpPr/>
           <p:nvPr/>
         </p:nvSpPr>
@@ -24491,7 +24785,7 @@
       </p:sp>
       <p:sp>
         <p:nvSpPr>
-          <p:cNvPr id="113" name="Shape 106"/>
+          <p:cNvPr id="115" name="Shape 108"/>
           <p:cNvSpPr/>
           <p:nvPr/>
         </p:nvSpPr>
@@ -24533,7 +24827,7 @@
       </p:sp>
       <p:sp>
         <p:nvSpPr>
-          <p:cNvPr id="114" name="Text 107"/>
+          <p:cNvPr id="116" name="Text 109"/>
           <p:cNvSpPr txBox="1"/>
           <p:nvPr/>
         </p:nvSpPr>
@@ -24568,7 +24862,7 @@
       </p:sp>
       <p:sp>
         <p:nvSpPr>
-          <p:cNvPr id="115" name="Text 108"/>
+          <p:cNvPr id="117" name="Text 110"/>
           <p:cNvSpPr txBox="1"/>
           <p:nvPr/>
         </p:nvSpPr>
@@ -24602,7 +24896,7 @@
       </p:sp>
       <p:sp>
         <p:nvSpPr>
-          <p:cNvPr id="116" name="Text 109"/>
+          <p:cNvPr id="118" name="Text 111"/>
           <p:cNvSpPr txBox="1"/>
           <p:nvPr/>
         </p:nvSpPr>
@@ -24636,7 +24930,7 @@
       </p:sp>
       <p:sp>
         <p:nvSpPr>
-          <p:cNvPr id="117" name="Text 110"/>
+          <p:cNvPr id="119" name="Text 112"/>
           <p:cNvSpPr txBox="1"/>
           <p:nvPr/>
         </p:nvSpPr>
@@ -24670,7 +24964,7 @@
       </p:sp>
       <p:sp>
         <p:nvSpPr>
-          <p:cNvPr id="118" name="Shape 111"/>
+          <p:cNvPr id="120" name="Shape 113"/>
           <p:cNvSpPr/>
           <p:nvPr/>
         </p:nvSpPr>
@@ -24714,7 +25008,7 @@
       </p:sp>
       <p:sp>
         <p:nvSpPr>
-          <p:cNvPr id="119" name="Text 112"/>
+          <p:cNvPr id="121" name="Text 114"/>
           <p:cNvSpPr txBox="1"/>
           <p:nvPr/>
         </p:nvSpPr>
@@ -24748,7 +25042,7 @@
       </p:sp>
       <p:sp>
         <p:nvSpPr>
-          <p:cNvPr id="120" name="Text 113"/>
+          <p:cNvPr id="122" name="Text 115"/>
           <p:cNvSpPr txBox="1"/>
           <p:nvPr/>
         </p:nvSpPr>
@@ -24793,7 +25087,7 @@
       </p:sp>
       <p:pic>
         <p:nvPicPr>
-          <p:cNvPr id="121" name="Picture 120" descr="salesforce.png"/>
+          <p:cNvPr id="123" name="Picture 122" descr="salesforce.png"/>
           <p:cNvPicPr>
             <a:picLocks noChangeAspect="1"/>
           </p:cNvPicPr>
@@ -24817,7 +25111,7 @@
       </p:pic>
       <p:sp>
         <p:nvSpPr>
-          <p:cNvPr id="122" name="Text 114"/>
+          <p:cNvPr id="124" name="Text 116"/>
           <p:cNvSpPr txBox="1"/>
           <p:nvPr/>
         </p:nvSpPr>
@@ -24851,7 +25145,7 @@
       </p:sp>
       <p:sp>
         <p:nvSpPr>
-          <p:cNvPr id="123" name="Text 115"/>
+          <p:cNvPr id="125" name="Text 117"/>
           <p:cNvSpPr txBox="1"/>
           <p:nvPr/>
         </p:nvSpPr>
@@ -24885,7 +25179,7 @@
       </p:sp>
       <p:pic>
         <p:nvPicPr>
-          <p:cNvPr id="124" name="Picture 123" descr="git.png"/>
+          <p:cNvPr id="126" name="Picture 125" descr="git.png"/>
           <p:cNvPicPr>
             <a:picLocks noChangeAspect="1"/>
           </p:cNvPicPr>
@@ -24909,7 +25203,7 @@
       </p:pic>
       <p:sp>
         <p:nvSpPr>
-          <p:cNvPr id="125" name="Text 116"/>
+          <p:cNvPr id="127" name="Text 118"/>
           <p:cNvSpPr txBox="1"/>
           <p:nvPr/>
         </p:nvSpPr>
@@ -24943,7 +25237,7 @@
       </p:sp>
       <p:sp>
         <p:nvSpPr>
-          <p:cNvPr id="126" name="Text 117"/>
+          <p:cNvPr id="128" name="Text 119"/>
           <p:cNvSpPr txBox="1"/>
           <p:nvPr/>
         </p:nvSpPr>
@@ -24977,7 +25271,7 @@
       </p:sp>
       <p:pic>
         <p:nvPicPr>
-          <p:cNvPr id="127" name="Picture 126" descr="googlebigquery.png"/>
+          <p:cNvPr id="129" name="Picture 128" descr="googlebigquery.png"/>
           <p:cNvPicPr>
             <a:picLocks noChangeAspect="1"/>
           </p:cNvPicPr>
@@ -25001,7 +25295,7 @@
       </p:pic>
       <p:sp>
         <p:nvSpPr>
-          <p:cNvPr id="128" name="Text 118"/>
+          <p:cNvPr id="130" name="Text 120"/>
           <p:cNvSpPr txBox="1"/>
           <p:nvPr/>
         </p:nvSpPr>
@@ -25035,7 +25329,7 @@
       </p:sp>
       <p:sp>
         <p:nvSpPr>
-          <p:cNvPr id="129" name="Text 119"/>
+          <p:cNvPr id="131" name="Text 121"/>
           <p:cNvSpPr txBox="1"/>
           <p:nvPr/>
         </p:nvSpPr>
@@ -25069,7 +25363,7 @@
       </p:sp>
       <p:pic>
         <p:nvPicPr>
-          <p:cNvPr id="130" name="Picture 129" descr="openai-white.png"/>
+          <p:cNvPr id="132" name="Picture 131" descr="openai-white.png"/>
           <p:cNvPicPr>
             <a:picLocks noChangeAspect="1"/>
           </p:cNvPicPr>
@@ -25093,7 +25387,7 @@
       </p:pic>
       <p:sp>
         <p:nvSpPr>
-          <p:cNvPr id="131" name="Text 120"/>
+          <p:cNvPr id="133" name="Text 122"/>
           <p:cNvSpPr txBox="1"/>
           <p:nvPr/>
         </p:nvSpPr>
@@ -25127,7 +25421,7 @@
       </p:sp>
       <p:sp>
         <p:nvSpPr>
-          <p:cNvPr id="132" name="Text 121"/>
+          <p:cNvPr id="134" name="Text 123"/>
           <p:cNvSpPr txBox="1"/>
           <p:nvPr/>
         </p:nvSpPr>
@@ -25161,7 +25455,7 @@
       </p:sp>
       <p:pic>
         <p:nvPicPr>
-          <p:cNvPr id="133" name="Picture 132" descr="googlecloud.png"/>
+          <p:cNvPr id="135" name="Picture 134" descr="googlecloud.png"/>
           <p:cNvPicPr>
             <a:picLocks noChangeAspect="1"/>
           </p:cNvPicPr>
@@ -25185,7 +25479,7 @@
       </p:pic>
       <p:sp>
         <p:nvSpPr>
-          <p:cNvPr id="134" name="Text 122"/>
+          <p:cNvPr id="136" name="Text 124"/>
           <p:cNvSpPr txBox="1"/>
           <p:nvPr/>
         </p:nvSpPr>
@@ -25219,7 +25513,7 @@
       </p:sp>
       <p:sp>
         <p:nvSpPr>
-          <p:cNvPr id="135" name="Text 123"/>
+          <p:cNvPr id="137" name="Text 125"/>
           <p:cNvSpPr txBox="1"/>
           <p:nvPr/>
         </p:nvSpPr>
@@ -26178,7 +26472,7 @@
                 </a:solidFill>
                 <a:latin typeface="Trenda IG Text"/>
               </a:rPr>
-              <a:t>Brief from the Jira story + Confluence design; open questions flagged.</a:t>
+              <a:t>User stories and functional decomposition from the Jira story; open questions flagged.</a:t>
             </a:r>
           </a:p>
         </p:txBody>

</xml_diff>

<commit_message>
Health Cloud timeline: agent working hours, Day 1 and Day 2
- Developer 4h, Review + Test 4h, Release 2h, UAT and production 8h (with
  requirements 3h and architect 5h): ~26 working hours. Day 1 takes the story
  to UAT; day 2 is UAT, CAB and production. No Day 0 on the axes.
- Grey "today" bars use a mid grey with dark labels so they read in the
  white deck too (campaign timeline included).

Co-Authored-By: Claude Opus 5.5 <noreply@anthropic.com>
Claude-Session: https://claude.ai/code/session_01Hf94kqMzSofkkrQm7kpNba
</commit_message>
<xml_diff>
--- a/poc/data_harness/Ascension Agentic Harness - Data Harness (white).pptx
+++ b/poc/data_harness/Ascension Agentic Harness - Data Harness (white).pptx
@@ -2152,7 +2152,7 @@
           </a:p>
           <a:p>
             <a:r>
-              <a:t>A typical Health Cloud task on the Network Services pod, from Jira story to UAT sign-off, takes about two weeks today. On the Agentic Harness the same task takes about two days. People still approve at every gate.</a:t>
+              <a:t>A typical Health Cloud task on the Network Services pod takes about two weeks today, from Jira story to UAT sign-off. On the Agentic Harness the same task goes from story to production in about two days. People still approve at every gate.</a:t>
             </a:r>
           </a:p>
           <a:p/>
@@ -2174,7 +2174,17 @@
           </a:p>
           <a:p>
             <a:r>
-              <a:t>The same seven delivery agents as every pod, with Health Cloud skills. Day 1 morning: the Requirements Agent turns the story into a brief and the product owner approves (H1); the Architect Agent reads impact and reuse from the knowledge graph, the Change Guardian names affected pods, and the architect and pod owners approve (H2). Day 1 afternoon and overnight: the Developer Agent builds in DEV. Day 2: the Review and Test Agents check code, security and sharing and run the tests, and the tech lead approves (H3); the Release Agent promotes through Copado to SIT and UAT; the business signs UAT (H4).</a:t>
+              <a:t>The same seven delivery agents as every pod, with Health Cloud skills; about 26 working hours over two days.</a:t>
+            </a:r>
+          </a:p>
+          <a:p>
+            <a:r>
+              <a:t>Day 1: the Requirements Agent turns the story into a brief in about 3 hours and the product owner approves (H1); the Architect Agent reads impact and reuse from the knowledge graph in about 5 hours, the Change Guardian names affected pods, and the architect and pod owners approve (H2). The Developer Agent builds in DEV in about 4 hours; the Review and Test Agents check code, security and sharing and run the tests in about 4 hours, and the tech lead approves (H3); the Release Agent promotes through Copado to SIT and UAT in about 2 hours.</a:t>
+            </a:r>
+          </a:p>
+          <a:p>
+            <a:r>
+              <a:t>Day 2: about 8 hours of business UAT (H4), CAB approval and the owning team's deployment to production.</a:t>
             </a:r>
           </a:p>
           <a:p/>
@@ -2185,7 +2195,7 @@
           </a:p>
           <a:p>
             <a:r>
-              <a:t>About 80% faster: 10 working days to about 2 days. Already measured with agent-assisted delivery: 1-2 weeks down to 2-4 days. The graph, the overnight build and the automated tests take it to about 2 days: the target, confirmed against the Phase 0 baseline.</a:t>
+              <a:t>About 80% faster: 10 working days to about 2 days. Already measured with agent-assisted delivery: 1-2 weeks down to 2-4 days. The graph, the agent build and the automated tests take it to about 2 days, story to production: the target, confirmed against the Phase 0 baseline.</a:t>
             </a:r>
           </a:p>
           <a:p/>
@@ -2201,7 +2211,12 @@
           </a:p>
           <a:p>
             <a:r>
-              <a:t>- "And production?" It still goes through CAB in its normal window; the two days are story to UAT sign-off.</a:t>
+              <a:t>- "Does CAB meet every day?" Day 2 assumes a CAB slot; otherwise production waits for the next CAB window. The agents never deploy to production.</a:t>
+            </a:r>
+          </a:p>
+          <a:p>
+            <a:r>
+              <a:t>- "Why only 4 hours to build?" A typical Health Cloud task is a validation rule, a Flow or a small Apex change; the agent builds it with the design already approved and the context from the graph.</a:t>
             </a:r>
           </a:p>
         </p:txBody>
@@ -5152,7 +5167,7 @@
             </a:avLst>
           </a:prstGeom>
           <a:solidFill>
-            <a:srgbClr val="E6E6E6"/>
+            <a:srgbClr val="9E9E9E"/>
           </a:solidFill>
           <a:ln>
             <a:noFill/>
@@ -5205,7 +5220,7 @@
             <a:r>
               <a:rPr sz="700" b="1" i="0">
                 <a:solidFill>
-                  <a:srgbClr val="FFFFFE"/>
+                  <a:srgbClr val="000000"/>
                 </a:solidFill>
                 <a:latin typeface="Trenda IG Text"/>
               </a:rPr>
@@ -5318,7 +5333,7 @@
             </a:avLst>
           </a:prstGeom>
           <a:solidFill>
-            <a:srgbClr val="E6E6E6"/>
+            <a:srgbClr val="9E9E9E"/>
           </a:solidFill>
           <a:ln>
             <a:noFill/>
@@ -5371,7 +5386,7 @@
             <a:r>
               <a:rPr sz="700" b="1" i="0">
                 <a:solidFill>
-                  <a:srgbClr val="FFFFFE"/>
+                  <a:srgbClr val="000000"/>
                 </a:solidFill>
                 <a:latin typeface="Trenda IG Text"/>
               </a:rPr>
@@ -5484,7 +5499,7 @@
             </a:avLst>
           </a:prstGeom>
           <a:solidFill>
-            <a:srgbClr val="E6E6E6"/>
+            <a:srgbClr val="9E9E9E"/>
           </a:solidFill>
           <a:ln>
             <a:noFill/>
@@ -5537,7 +5552,7 @@
             <a:r>
               <a:rPr sz="700" b="1" i="0">
                 <a:solidFill>
-                  <a:srgbClr val="FFFFFE"/>
+                  <a:srgbClr val="000000"/>
                 </a:solidFill>
                 <a:latin typeface="Trenda IG Text"/>
               </a:rPr>
@@ -5650,7 +5665,7 @@
             </a:avLst>
           </a:prstGeom>
           <a:solidFill>
-            <a:srgbClr val="E6E6E6"/>
+            <a:srgbClr val="9E9E9E"/>
           </a:solidFill>
           <a:ln>
             <a:noFill/>
@@ -5703,7 +5718,7 @@
             <a:r>
               <a:rPr sz="700" b="1" i="0">
                 <a:solidFill>
-                  <a:srgbClr val="FFFFFE"/>
+                  <a:srgbClr val="000000"/>
                 </a:solidFill>
                 <a:latin typeface="Trenda IG Text"/>
               </a:rPr>
@@ -5816,7 +5831,7 @@
             </a:avLst>
           </a:prstGeom>
           <a:solidFill>
-            <a:srgbClr val="E6E6E6"/>
+            <a:srgbClr val="9E9E9E"/>
           </a:solidFill>
           <a:ln>
             <a:noFill/>
@@ -5869,7 +5884,7 @@
             <a:r>
               <a:rPr sz="700" b="1" i="0">
                 <a:solidFill>
-                  <a:srgbClr val="FFFFFE"/>
+                  <a:srgbClr val="000000"/>
                 </a:solidFill>
                 <a:latin typeface="Trenda IG Text"/>
               </a:rPr>
@@ -41895,7 +41910,7 @@
                 </a:solidFill>
                 <a:latin typeface="Trenda IG Text"/>
               </a:rPr>
-              <a:t>Any Health Cloud task, Jira story to UAT sign-off. The same seven delivery agents with Health Cloud skills; agents build overnight, people approve by day.</a:t>
+              <a:t>Any Health Cloud task. The same seven delivery agents with Health Cloud skills: day 1 takes the story to UAT, day 2 is UAT and production. People approve at every gate.</a:t>
             </a:r>
           </a:p>
         </p:txBody>
@@ -42668,7 +42683,7 @@
             </a:avLst>
           </a:prstGeom>
           <a:solidFill>
-            <a:srgbClr val="E6E6E6"/>
+            <a:srgbClr val="9E9E9E"/>
           </a:solidFill>
           <a:ln>
             <a:noFill/>
@@ -42721,7 +42736,7 @@
             <a:r>
               <a:rPr sz="700" b="1" i="0">
                 <a:solidFill>
-                  <a:srgbClr val="FFFFFE"/>
+                  <a:srgbClr val="000000"/>
                 </a:solidFill>
                 <a:latin typeface="Trenda IG Text"/>
               </a:rPr>
@@ -42834,7 +42849,7 @@
             </a:avLst>
           </a:prstGeom>
           <a:solidFill>
-            <a:srgbClr val="E6E6E6"/>
+            <a:srgbClr val="9E9E9E"/>
           </a:solidFill>
           <a:ln>
             <a:noFill/>
@@ -42887,7 +42902,7 @@
             <a:r>
               <a:rPr sz="700" b="1" i="0">
                 <a:solidFill>
-                  <a:srgbClr val="FFFFFE"/>
+                  <a:srgbClr val="000000"/>
                 </a:solidFill>
                 <a:latin typeface="Trenda IG Text"/>
               </a:rPr>
@@ -43000,7 +43015,7 @@
             </a:avLst>
           </a:prstGeom>
           <a:solidFill>
-            <a:srgbClr val="E6E6E6"/>
+            <a:srgbClr val="9E9E9E"/>
           </a:solidFill>
           <a:ln>
             <a:noFill/>
@@ -43053,7 +43068,7 @@
             <a:r>
               <a:rPr sz="700" b="1" i="0">
                 <a:solidFill>
-                  <a:srgbClr val="FFFFFE"/>
+                  <a:srgbClr val="000000"/>
                 </a:solidFill>
                 <a:latin typeface="Trenda IG Text"/>
               </a:rPr>
@@ -43332,7 +43347,7 @@
             </a:avLst>
           </a:prstGeom>
           <a:solidFill>
-            <a:srgbClr val="E6E6E6"/>
+            <a:srgbClr val="9E9E9E"/>
           </a:solidFill>
           <a:ln>
             <a:noFill/>
@@ -43385,7 +43400,7 @@
             <a:r>
               <a:rPr sz="700" b="1" i="0">
                 <a:solidFill>
-                  <a:srgbClr val="FFFFFE"/>
+                  <a:srgbClr val="000000"/>
                 </a:solidFill>
                 <a:latin typeface="Trenda IG Text"/>
               </a:rPr>
@@ -43498,7 +43513,7 @@
             </a:avLst>
           </a:prstGeom>
           <a:solidFill>
-            <a:srgbClr val="E6E6E6"/>
+            <a:srgbClr val="9E9E9E"/>
           </a:solidFill>
           <a:ln>
             <a:noFill/>
@@ -43551,7 +43566,7 @@
             <a:r>
               <a:rPr sz="700" b="1" i="0">
                 <a:solidFill>
-                  <a:srgbClr val="FFFFFE"/>
+                  <a:srgbClr val="000000"/>
                 </a:solidFill>
                 <a:latin typeface="Trenda IG Text"/>
               </a:rPr>
@@ -43568,7 +43583,7 @@
         </p:nvSpPr>
         <p:spPr>
           <a:xfrm>
-            <a:off x="2331720" y="1865375"/>
+            <a:off x="2494026" y="1865375"/>
             <a:ext cx="548640" cy="146304"/>
           </a:xfrm>
           <a:prstGeom prst="rect">
@@ -43590,7 +43605,7 @@
                 </a:solidFill>
                 <a:latin typeface="Trenda IG Text"/>
               </a:rPr>
-              <a:t>Day 0</a:t>
+              <a:t>Day 1</a:t>
             </a:r>
           </a:p>
         </p:txBody>
@@ -43603,7 +43618,7 @@
         </p:nvSpPr>
         <p:spPr>
           <a:xfrm>
-            <a:off x="3954780" y="1865375"/>
+            <a:off x="3792474" y="1865375"/>
             <a:ext cx="548640" cy="146304"/>
           </a:xfrm>
           <a:prstGeom prst="rect">
@@ -43638,7 +43653,7 @@
         </p:nvSpPr>
         <p:spPr>
           <a:xfrm>
-            <a:off x="5577840" y="1865375"/>
+            <a:off x="5415534" y="1865375"/>
             <a:ext cx="548640" cy="146304"/>
           </a:xfrm>
           <a:prstGeom prst="rect">
@@ -43857,7 +43872,7 @@
                 </a:solidFill>
                 <a:latin typeface="Trenda IG Text"/>
               </a:rPr>
-              <a:t>~48 hours elapsed: agents build overnight, people approve by day</a:t>
+              <a:t>~26 working hours: day 1 story to UAT, day 2 UAT and production</a:t>
             </a:r>
           </a:p>
         </p:txBody>
@@ -43958,7 +43973,7 @@
         <p:spPr>
           <a:xfrm>
             <a:off x="8540496" y="2148839"/>
-            <a:ext cx="274320" cy="201168"/>
+            <a:ext cx="352395" cy="201168"/>
           </a:xfrm>
           <a:prstGeom prst="roundRect">
             <a:avLst>
@@ -44002,7 +44017,7 @@
         <p:spPr>
           <a:xfrm>
             <a:off x="8540496" y="2148839"/>
-            <a:ext cx="274320" cy="201168"/>
+            <a:ext cx="352395" cy="201168"/>
           </a:xfrm>
           <a:prstGeom prst="rect">
             <a:avLst/>
@@ -44123,8 +44138,8 @@
         </p:nvSpPr>
         <p:spPr>
           <a:xfrm>
-            <a:off x="8731377" y="2560320"/>
-            <a:ext cx="318134" cy="201168"/>
+            <a:off x="8892891" y="2560320"/>
+            <a:ext cx="587326" cy="201168"/>
           </a:xfrm>
           <a:prstGeom prst="roundRect">
             <a:avLst>
@@ -44167,8 +44182,8 @@
         </p:nvSpPr>
         <p:spPr>
           <a:xfrm>
-            <a:off x="8731377" y="2560320"/>
-            <a:ext cx="318134" cy="201168"/>
+            <a:off x="8892891" y="2560320"/>
+            <a:ext cx="587326" cy="201168"/>
           </a:xfrm>
           <a:prstGeom prst="rect">
             <a:avLst/>
@@ -44276,7 +44291,7 @@
                 </a:solidFill>
                 <a:latin typeface="Trenda IG Text"/>
               </a:rPr>
-              <a:t>Apex, LWC, Flows, sharing in DEV, overnight</a:t>
+              <a:t>Apex, LWC, Flows, sharing in DEV</a:t>
             </a:r>
           </a:p>
         </p:txBody>
@@ -44289,8 +44304,8 @@
         </p:nvSpPr>
         <p:spPr>
           <a:xfrm>
-            <a:off x="9049512" y="2971799"/>
-            <a:ext cx="1018032" cy="201168"/>
+            <a:off x="9480217" y="2971799"/>
+            <a:ext cx="469860" cy="201168"/>
           </a:xfrm>
           <a:prstGeom prst="roundRect">
             <a:avLst>
@@ -44333,8 +44348,8 @@
         </p:nvSpPr>
         <p:spPr>
           <a:xfrm>
-            <a:off x="9049512" y="2971799"/>
-            <a:ext cx="1018032" cy="201168"/>
+            <a:off x="9480217" y="2971799"/>
+            <a:ext cx="469860" cy="201168"/>
           </a:xfrm>
           <a:prstGeom prst="rect">
             <a:avLst/>
@@ -44355,7 +44370,7 @@
                 </a:solidFill>
                 <a:latin typeface="Trenda IG Text"/>
               </a:rPr>
-              <a:t>16h</a:t>
+              <a:t>4h</a:t>
             </a:r>
           </a:p>
         </p:txBody>
@@ -44455,8 +44470,8 @@
         </p:nvSpPr>
         <p:spPr>
           <a:xfrm>
-            <a:off x="10067544" y="3383279"/>
-            <a:ext cx="509016" cy="201168"/>
+            <a:off x="9950078" y="3383279"/>
+            <a:ext cx="469860" cy="201168"/>
           </a:xfrm>
           <a:prstGeom prst="roundRect">
             <a:avLst>
@@ -44499,8 +44514,8 @@
         </p:nvSpPr>
         <p:spPr>
           <a:xfrm>
-            <a:off x="10067544" y="3383279"/>
-            <a:ext cx="509016" cy="201168"/>
+            <a:off x="9950078" y="3383279"/>
+            <a:ext cx="469860" cy="201168"/>
           </a:xfrm>
           <a:prstGeom prst="rect">
             <a:avLst/>
@@ -44521,7 +44536,7 @@
                 </a:solidFill>
                 <a:latin typeface="Trenda IG Text"/>
               </a:rPr>
-              <a:t>8h</a:t>
+              <a:t>4h</a:t>
             </a:r>
           </a:p>
         </p:txBody>
@@ -44621,8 +44636,8 @@
         </p:nvSpPr>
         <p:spPr>
           <a:xfrm>
-            <a:off x="10576560" y="3794759"/>
-            <a:ext cx="381762" cy="201168"/>
+            <a:off x="10419939" y="3794759"/>
+            <a:ext cx="274320" cy="201168"/>
           </a:xfrm>
           <a:prstGeom prst="roundRect">
             <a:avLst>
@@ -44665,8 +44680,8 @@
         </p:nvSpPr>
         <p:spPr>
           <a:xfrm>
-            <a:off x="10576560" y="3794759"/>
-            <a:ext cx="381762" cy="201168"/>
+            <a:off x="10419939" y="3794759"/>
+            <a:ext cx="274320" cy="201168"/>
           </a:xfrm>
           <a:prstGeom prst="rect">
             <a:avLst/>
@@ -44687,7 +44702,7 @@
                 </a:solidFill>
                 <a:latin typeface="Trenda IG Text"/>
               </a:rPr>
-              <a:t>6h</a:t>
+              <a:t>2h</a:t>
             </a:r>
           </a:p>
         </p:txBody>
@@ -44763,7 +44778,7 @@
                 </a:solidFill>
                 <a:latin typeface="Trenda IG Text"/>
               </a:rPr>
-              <a:t>Business UAT sign-off · H4</a:t>
+              <a:t>UAT + production · H4 · CAB</a:t>
             </a:r>
           </a:p>
           <a:p>
@@ -44774,7 +44789,7 @@
                 </a:solidFill>
                 <a:latin typeface="Trenda IG Text"/>
               </a:rPr>
-              <a:t>the business owner signs UAT</a:t>
+              <a:t>business signs UAT; CAB; the owning team deploys</a:t>
             </a:r>
           </a:p>
         </p:txBody>
@@ -44787,8 +44802,8 @@
         </p:nvSpPr>
         <p:spPr>
           <a:xfrm>
-            <a:off x="10958322" y="4206240"/>
-            <a:ext cx="636269" cy="201168"/>
+            <a:off x="10654870" y="4206240"/>
+            <a:ext cx="939721" cy="201168"/>
           </a:xfrm>
           <a:prstGeom prst="roundRect">
             <a:avLst>
@@ -44831,8 +44846,8 @@
         </p:nvSpPr>
         <p:spPr>
           <a:xfrm>
-            <a:off x="10958322" y="4206240"/>
-            <a:ext cx="636269" cy="201168"/>
+            <a:off x="10654870" y="4206240"/>
+            <a:ext cx="939721" cy="201168"/>
           </a:xfrm>
           <a:prstGeom prst="rect">
             <a:avLst/>
@@ -44853,7 +44868,7 @@
                 </a:solidFill>
                 <a:latin typeface="Trenda IG Text"/>
               </a:rPr>
-              <a:t>10h</a:t>
+              <a:t>8h</a:t>
             </a:r>
           </a:p>
         </p:txBody>
@@ -44866,7 +44881,7 @@
         </p:nvSpPr>
         <p:spPr>
           <a:xfrm>
-            <a:off x="8266175" y="1865375"/>
+            <a:off x="9323363" y="1865375"/>
             <a:ext cx="548640" cy="146304"/>
           </a:xfrm>
           <a:prstGeom prst="rect">
@@ -44888,7 +44903,7 @@
                 </a:solidFill>
                 <a:latin typeface="Trenda IG Text"/>
               </a:rPr>
-              <a:t>Day 0</a:t>
+              <a:t>Day 1</a:t>
             </a:r>
           </a:p>
         </p:txBody>
@@ -44901,7 +44916,7 @@
         </p:nvSpPr>
         <p:spPr>
           <a:xfrm>
-            <a:off x="9793224" y="1865375"/>
+            <a:off x="10850411" y="1865375"/>
             <a:ext cx="548640" cy="146304"/>
           </a:xfrm>
           <a:prstGeom prst="rect">
@@ -44923,44 +44938,51 @@
                 </a:solidFill>
                 <a:latin typeface="Trenda IG Text"/>
               </a:rPr>
-              <a:t>Day 1</a:t>
-            </a:r>
-          </a:p>
-        </p:txBody>
-      </p:sp>
-      <p:sp>
-        <p:nvSpPr>
-          <p:cNvPr id="79" name="Text 79"/>
-          <p:cNvSpPr txBox="1"/>
-          <p:nvPr/>
-        </p:nvSpPr>
-        <p:spPr>
-          <a:xfrm>
-            <a:off x="11320272" y="1865375"/>
-            <a:ext cx="548640" cy="146304"/>
-          </a:xfrm>
-          <a:prstGeom prst="rect">
-            <a:avLst/>
-          </a:prstGeom>
-          <a:noFill/>
-        </p:spPr>
-        <p:txBody>
-          <a:bodyPr wrap="square" lIns="0" rIns="0" tIns="0" bIns="0" anchor="ctr">
-            <a:spAutoFit/>
-          </a:bodyPr>
-          <a:lstStyle/>
-          <a:p>
-            <a:pPr algn="ctr"/>
-            <a:r>
-              <a:rPr sz="700" b="0" i="0">
-                <a:solidFill>
-                  <a:srgbClr val="6B6B6B"/>
-                </a:solidFill>
-                <a:latin typeface="Trenda IG Text"/>
-              </a:rPr>
               <a:t>Day 2</a:t>
             </a:r>
           </a:p>
+        </p:txBody>
+      </p:sp>
+      <p:sp>
+        <p:nvSpPr>
+          <p:cNvPr id="79" name="Shape 79"/>
+          <p:cNvSpPr/>
+          <p:nvPr/>
+        </p:nvSpPr>
+        <p:spPr>
+          <a:xfrm>
+            <a:off x="10707975" y="2011679"/>
+            <a:ext cx="9144" cy="2478024"/>
+          </a:xfrm>
+          <a:prstGeom prst="rect">
+            <a:avLst/>
+          </a:prstGeom>
+          <a:solidFill>
+            <a:srgbClr val="E6E6E6"/>
+          </a:solidFill>
+          <a:ln>
+            <a:noFill/>
+          </a:ln>
+          <a:effectLst/>
+        </p:spPr>
+        <p:style>
+          <a:lnRef idx="1">
+            <a:schemeClr val="accent1"/>
+          </a:lnRef>
+          <a:fillRef idx="3">
+            <a:schemeClr val="accent1"/>
+          </a:fillRef>
+          <a:effectRef idx="2">
+            <a:schemeClr val="accent1"/>
+          </a:effectRef>
+          <a:fontRef idx="minor">
+            <a:schemeClr val="lt1"/>
+          </a:fontRef>
+        </p:style>
+        <p:txBody>
+          <a:bodyPr rtlCol="0" anchor="ctr"/>
+          <a:lstStyle/>
+          <a:p/>
         </p:txBody>
       </p:sp>
       <p:sp>
@@ -44971,7 +44993,7 @@
         </p:nvSpPr>
         <p:spPr>
           <a:xfrm>
-            <a:off x="8860536" y="2148839"/>
+            <a:off x="8938611" y="2148839"/>
             <a:ext cx="310896" cy="201168"/>
           </a:xfrm>
           <a:prstGeom prst="roundRect">
@@ -45015,7 +45037,7 @@
         </p:nvSpPr>
         <p:spPr>
           <a:xfrm>
-            <a:off x="8860536" y="2148839"/>
+            <a:off x="8938611" y="2148839"/>
             <a:ext cx="310896" cy="201168"/>
           </a:xfrm>
           <a:prstGeom prst="rect">
@@ -45050,7 +45072,7 @@
         </p:nvSpPr>
         <p:spPr>
           <a:xfrm>
-            <a:off x="9095232" y="2560320"/>
+            <a:off x="9525937" y="2560320"/>
             <a:ext cx="310896" cy="201168"/>
           </a:xfrm>
           <a:prstGeom prst="roundRect">
@@ -45094,7 +45116,7 @@
         </p:nvSpPr>
         <p:spPr>
           <a:xfrm>
-            <a:off x="9095232" y="2560320"/>
+            <a:off x="9525937" y="2560320"/>
             <a:ext cx="310896" cy="201168"/>
           </a:xfrm>
           <a:prstGeom prst="rect">
@@ -45129,7 +45151,7 @@
         </p:nvSpPr>
         <p:spPr>
           <a:xfrm>
-            <a:off x="10622280" y="3383279"/>
+            <a:off x="10465659" y="3383279"/>
             <a:ext cx="310896" cy="201168"/>
           </a:xfrm>
           <a:prstGeom prst="roundRect">
@@ -45173,7 +45195,7 @@
         </p:nvSpPr>
         <p:spPr>
           <a:xfrm>
-            <a:off x="10622280" y="3383279"/>
+            <a:off x="10465659" y="3383279"/>
             <a:ext cx="310896" cy="201168"/>
           </a:xfrm>
           <a:prstGeom prst="rect">
@@ -45229,7 +45251,7 @@
                 </a:solidFill>
                 <a:latin typeface="Trenda IG Text"/>
               </a:rPr>
-              <a:t>Production follows the normal CAB window. </a:t>
+              <a:t>Day 2 assumes a CAB slot; otherwise the next CAB window. </a:t>
             </a:r>
             <a:r>
               <a:rPr sz="700" b="0" i="0">
@@ -45412,7 +45434,7 @@
                 </a:solidFill>
                 <a:latin typeface="Trenda IG Text"/>
               </a:rPr>
-              <a:t>~10 working days to ~2 days</a:t>
+              <a:t>~10 working days to ~2 days, now to production</a:t>
             </a:r>
           </a:p>
         </p:txBody>
@@ -45934,7 +45956,7 @@
                 </a:solidFill>
                 <a:latin typeface="Trenda IG Text"/>
               </a:rPr>
-              <a:t>H1 brief, H2 design, H3 code, H4 UAT; then CAB</a:t>
+              <a:t>H1 brief, H2 design, H3 code, H4 UAT; plus CAB</a:t>
             </a:r>
           </a:p>
         </p:txBody>
@@ -45968,7 +45990,7 @@
                 </a:solidFill>
                 <a:latin typeface="Trenda IG Text"/>
               </a:rPr>
-              <a:t>Today: a typical Health Cloud task on the Network Services pod, Jira story to UAT sign-off. Measured: agent-assisted delivery at Ascension, 1-2 weeks to 2-4 days. ~2 days is the harness target, confirmed against the Phase 0 baseline.</a:t>
+              <a:t>Today: a typical Health Cloud task on the Network Services pod, Jira story to UAT sign-off. Measured: agent-assisted delivery at Ascension, 1-2 weeks to 2-4 days. ~2 days to production is the harness target, confirmed against the Phase 0 baseline.</a:t>
             </a:r>
           </a:p>
         </p:txBody>

</xml_diff>